<commit_message>
feat: add 12 UI features — skeleton loaders, toast notifications, back-to-top, copy button, empty states, sticky header scroll, mobile menu close-on-nav, cookie banner, skip-to-content, OpenGraph metadata, hover polish, brand-red scrollbar
</commit_message>
<xml_diff>
--- a/VERDICT_SIH2026_Official.pptx
+++ b/VERDICT_SIH2026_Official.pptx
@@ -5,7 +5,7 @@
     <p:sldMasterId id="2147483648" r:id="rId1"/>
   </p:sldMasterIdLst>
   <p:notesMasterIdLst>
-    <p:notesMasterId r:id="rId9"/>
+    <p:notesMasterId r:id="rId8"/>
   </p:notesMasterIdLst>
   <p:sldIdLst>
     <p:sldId id="291" r:id="rId2"/>
@@ -161,6 +161,390 @@
 </p:presentation>
 </file>
 
+<file path=ppt/changesInfos/changesInfo1.xml><?xml version="1.0" encoding="utf-8"?>
+<pc:chgInfo xmlns:a="http://schemas.openxmlformats.org/drawingml/2006/main" xmlns:r="http://schemas.openxmlformats.org/officeDocument/2006/relationships" xmlns:ac="http://schemas.microsoft.com/office/drawing/2013/main/command" xmlns:pc="http://schemas.microsoft.com/office/powerpoint/2013/main/command">
+  <pc:docChgLst>
+    <pc:chgData name="KARTIK JADHAV B1-2620" userId="31dafa177a7777d4" providerId="LiveId" clId="{381810DB-81FF-485E-B53B-9CA04A6EA75A}"/>
+    <pc:docChg chg="undo custSel modSld">
+      <pc:chgData name="KARTIK JADHAV B1-2620" userId="31dafa177a7777d4" providerId="LiveId" clId="{381810DB-81FF-485E-B53B-9CA04A6EA75A}" dt="2026-08-29T15:04:25.130" v="148" actId="255"/>
+      <pc:docMkLst>
+        <pc:docMk/>
+      </pc:docMkLst>
+      <pc:sldChg chg="delSp modSp mod">
+        <pc:chgData name="KARTIK JADHAV B1-2620" userId="31dafa177a7777d4" providerId="LiveId" clId="{381810DB-81FF-485E-B53B-9CA04A6EA75A}" dt="2026-08-29T14:52:22.709" v="32" actId="255"/>
+        <pc:sldMkLst>
+          <pc:docMk/>
+          <pc:sldMk cId="0" sldId="281"/>
+        </pc:sldMkLst>
+        <pc:spChg chg="del mod">
+          <ac:chgData name="KARTIK JADHAV B1-2620" userId="31dafa177a7777d4" providerId="LiveId" clId="{381810DB-81FF-485E-B53B-9CA04A6EA75A}" dt="2026-08-29T14:47:09.898" v="7" actId="478"/>
+          <ac:spMkLst>
+            <pc:docMk/>
+            <pc:sldMk cId="0" sldId="281"/>
+            <ac:spMk id="9" creationId="{00000000-0000-0000-0000-000000000000}"/>
+          </ac:spMkLst>
+        </pc:spChg>
+        <pc:spChg chg="mod">
+          <ac:chgData name="KARTIK JADHAV B1-2620" userId="31dafa177a7777d4" providerId="LiveId" clId="{381810DB-81FF-485E-B53B-9CA04A6EA75A}" dt="2026-08-29T14:48:43.481" v="14" actId="255"/>
+          <ac:spMkLst>
+            <pc:docMk/>
+            <pc:sldMk cId="0" sldId="281"/>
+            <ac:spMk id="15362" creationId="{00000000-0000-0000-0000-000000000000}"/>
+          </ac:spMkLst>
+        </pc:spChg>
+        <pc:spChg chg="mod">
+          <ac:chgData name="KARTIK JADHAV B1-2620" userId="31dafa177a7777d4" providerId="LiveId" clId="{381810DB-81FF-485E-B53B-9CA04A6EA75A}" dt="2026-08-29T14:52:22.709" v="32" actId="255"/>
+          <ac:spMkLst>
+            <pc:docMk/>
+            <pc:sldMk cId="0" sldId="281"/>
+            <ac:spMk id="15363" creationId="{00000000-0000-0000-0000-000000000000}"/>
+          </ac:spMkLst>
+        </pc:spChg>
+        <pc:spChg chg="mod">
+          <ac:chgData name="KARTIK JADHAV B1-2620" userId="31dafa177a7777d4" providerId="LiveId" clId="{381810DB-81FF-485E-B53B-9CA04A6EA75A}" dt="2026-08-29T14:47:21.765" v="8" actId="1076"/>
+          <ac:spMkLst>
+            <pc:docMk/>
+            <pc:sldMk cId="0" sldId="281"/>
+            <ac:spMk id="15364" creationId="{00000000-0000-0000-0000-000000000000}"/>
+          </ac:spMkLst>
+        </pc:spChg>
+        <pc:spChg chg="mod">
+          <ac:chgData name="KARTIK JADHAV B1-2620" userId="31dafa177a7777d4" providerId="LiveId" clId="{381810DB-81FF-485E-B53B-9CA04A6EA75A}" dt="2026-08-29T14:52:15.330" v="31" actId="255"/>
+          <ac:spMkLst>
+            <pc:docMk/>
+            <pc:sldMk cId="0" sldId="281"/>
+            <ac:spMk id="15365" creationId="{00000000-0000-0000-0000-000000000000}"/>
+          </ac:spMkLst>
+        </pc:spChg>
+        <pc:spChg chg="mod">
+          <ac:chgData name="KARTIK JADHAV B1-2620" userId="31dafa177a7777d4" providerId="LiveId" clId="{381810DB-81FF-485E-B53B-9CA04A6EA75A}" dt="2026-08-29T14:47:21.765" v="8" actId="1076"/>
+          <ac:spMkLst>
+            <pc:docMk/>
+            <pc:sldMk cId="0" sldId="281"/>
+            <ac:spMk id="15366" creationId="{00000000-0000-0000-0000-000000000000}"/>
+          </ac:spMkLst>
+        </pc:spChg>
+        <pc:spChg chg="mod">
+          <ac:chgData name="KARTIK JADHAV B1-2620" userId="31dafa177a7777d4" providerId="LiveId" clId="{381810DB-81FF-485E-B53B-9CA04A6EA75A}" dt="2026-08-29T14:52:05.631" v="30" actId="255"/>
+          <ac:spMkLst>
+            <pc:docMk/>
+            <pc:sldMk cId="0" sldId="281"/>
+            <ac:spMk id="15367" creationId="{00000000-0000-0000-0000-000000000000}"/>
+          </ac:spMkLst>
+        </pc:spChg>
+        <pc:spChg chg="mod">
+          <ac:chgData name="KARTIK JADHAV B1-2620" userId="31dafa177a7777d4" providerId="LiveId" clId="{381810DB-81FF-485E-B53B-9CA04A6EA75A}" dt="2026-08-29T14:47:21.765" v="8" actId="1076"/>
+          <ac:spMkLst>
+            <pc:docMk/>
+            <pc:sldMk cId="0" sldId="281"/>
+            <ac:spMk id="15368" creationId="{00000000-0000-0000-0000-000000000000}"/>
+          </ac:spMkLst>
+        </pc:spChg>
+        <pc:spChg chg="mod">
+          <ac:chgData name="KARTIK JADHAV B1-2620" userId="31dafa177a7777d4" providerId="LiveId" clId="{381810DB-81FF-485E-B53B-9CA04A6EA75A}" dt="2026-08-29T14:49:25.615" v="17" actId="255"/>
+          <ac:spMkLst>
+            <pc:docMk/>
+            <pc:sldMk cId="0" sldId="281"/>
+            <ac:spMk id="15369" creationId="{00000000-0000-0000-0000-000000000000}"/>
+          </ac:spMkLst>
+        </pc:spChg>
+      </pc:sldChg>
+      <pc:sldChg chg="delSp modSp mod">
+        <pc:chgData name="KARTIK JADHAV B1-2620" userId="31dafa177a7777d4" providerId="LiveId" clId="{381810DB-81FF-485E-B53B-9CA04A6EA75A}" dt="2026-08-29T14:53:20.305" v="37" actId="255"/>
+        <pc:sldMkLst>
+          <pc:docMk/>
+          <pc:sldMk cId="0" sldId="290"/>
+        </pc:sldMkLst>
+        <pc:spChg chg="del mod">
+          <ac:chgData name="KARTIK JADHAV B1-2620" userId="31dafa177a7777d4" providerId="LiveId" clId="{381810DB-81FF-485E-B53B-9CA04A6EA75A}" dt="2026-08-29T14:49:54.891" v="21" actId="478"/>
+          <ac:spMkLst>
+            <pc:docMk/>
+            <pc:sldMk cId="0" sldId="290"/>
+            <ac:spMk id="7" creationId="{00000000-0000-0000-0000-000000000000}"/>
+          </ac:spMkLst>
+        </pc:spChg>
+        <pc:spChg chg="del mod">
+          <ac:chgData name="KARTIK JADHAV B1-2620" userId="31dafa177a7777d4" providerId="LiveId" clId="{381810DB-81FF-485E-B53B-9CA04A6EA75A}" dt="2026-08-29T14:49:50.810" v="19" actId="478"/>
+          <ac:spMkLst>
+            <pc:docMk/>
+            <pc:sldMk cId="0" sldId="290"/>
+            <ac:spMk id="10" creationId="{AD4F69D3-EEB0-4C4C-9434-B9960FB5854C}"/>
+          </ac:spMkLst>
+        </pc:spChg>
+        <pc:spChg chg="mod">
+          <ac:chgData name="KARTIK JADHAV B1-2620" userId="31dafa177a7777d4" providerId="LiveId" clId="{381810DB-81FF-485E-B53B-9CA04A6EA75A}" dt="2026-08-29T14:51:12.600" v="26" actId="255"/>
+          <ac:spMkLst>
+            <pc:docMk/>
+            <pc:sldMk cId="0" sldId="290"/>
+            <ac:spMk id="17410" creationId="{00000000-0000-0000-0000-000000000000}"/>
+          </ac:spMkLst>
+        </pc:spChg>
+        <pc:spChg chg="mod">
+          <ac:chgData name="KARTIK JADHAV B1-2620" userId="31dafa177a7777d4" providerId="LiveId" clId="{381810DB-81FF-485E-B53B-9CA04A6EA75A}" dt="2026-08-29T14:52:40.547" v="33" actId="255"/>
+          <ac:spMkLst>
+            <pc:docMk/>
+            <pc:sldMk cId="0" sldId="290"/>
+            <ac:spMk id="17411" creationId="{00000000-0000-0000-0000-000000000000}"/>
+          </ac:spMkLst>
+        </pc:spChg>
+        <pc:spChg chg="mod">
+          <ac:chgData name="KARTIK JADHAV B1-2620" userId="31dafa177a7777d4" providerId="LiveId" clId="{381810DB-81FF-485E-B53B-9CA04A6EA75A}" dt="2026-08-29T14:52:48.673" v="34" actId="255"/>
+          <ac:spMkLst>
+            <pc:docMk/>
+            <pc:sldMk cId="0" sldId="290"/>
+            <ac:spMk id="17412" creationId="{00000000-0000-0000-0000-000000000000}"/>
+          </ac:spMkLst>
+        </pc:spChg>
+        <pc:spChg chg="mod">
+          <ac:chgData name="KARTIK JADHAV B1-2620" userId="31dafa177a7777d4" providerId="LiveId" clId="{381810DB-81FF-485E-B53B-9CA04A6EA75A}" dt="2026-08-29T14:52:58.007" v="35" actId="255"/>
+          <ac:spMkLst>
+            <pc:docMk/>
+            <pc:sldMk cId="0" sldId="290"/>
+            <ac:spMk id="17413" creationId="{00000000-0000-0000-0000-000000000000}"/>
+          </ac:spMkLst>
+        </pc:spChg>
+        <pc:spChg chg="mod">
+          <ac:chgData name="KARTIK JADHAV B1-2620" userId="31dafa177a7777d4" providerId="LiveId" clId="{381810DB-81FF-485E-B53B-9CA04A6EA75A}" dt="2026-08-29T14:53:08.865" v="36" actId="255"/>
+          <ac:spMkLst>
+            <pc:docMk/>
+            <pc:sldMk cId="0" sldId="290"/>
+            <ac:spMk id="17414" creationId="{00000000-0000-0000-0000-000000000000}"/>
+          </ac:spMkLst>
+        </pc:spChg>
+        <pc:spChg chg="mod">
+          <ac:chgData name="KARTIK JADHAV B1-2620" userId="31dafa177a7777d4" providerId="LiveId" clId="{381810DB-81FF-485E-B53B-9CA04A6EA75A}" dt="2026-08-29T14:50:09.330" v="22" actId="1076"/>
+          <ac:spMkLst>
+            <pc:docMk/>
+            <pc:sldMk cId="0" sldId="290"/>
+            <ac:spMk id="17415" creationId="{00000000-0000-0000-0000-000000000000}"/>
+          </ac:spMkLst>
+        </pc:spChg>
+        <pc:spChg chg="mod">
+          <ac:chgData name="KARTIK JADHAV B1-2620" userId="31dafa177a7777d4" providerId="LiveId" clId="{381810DB-81FF-485E-B53B-9CA04A6EA75A}" dt="2026-08-29T14:53:20.305" v="37" actId="255"/>
+          <ac:spMkLst>
+            <pc:docMk/>
+            <pc:sldMk cId="0" sldId="290"/>
+            <ac:spMk id="17416" creationId="{00000000-0000-0000-0000-000000000000}"/>
+          </ac:spMkLst>
+        </pc:spChg>
+      </pc:sldChg>
+      <pc:sldChg chg="modSp mod">
+        <pc:chgData name="KARTIK JADHAV B1-2620" userId="31dafa177a7777d4" providerId="LiveId" clId="{381810DB-81FF-485E-B53B-9CA04A6EA75A}" dt="2026-08-29T14:46:07.462" v="3" actId="255"/>
+        <pc:sldMkLst>
+          <pc:docMk/>
+          <pc:sldMk cId="0" sldId="291"/>
+        </pc:sldMkLst>
+        <pc:spChg chg="mod">
+          <ac:chgData name="KARTIK JADHAV B1-2620" userId="31dafa177a7777d4" providerId="LiveId" clId="{381810DB-81FF-485E-B53B-9CA04A6EA75A}" dt="2026-08-29T14:46:07.462" v="3" actId="255"/>
+          <ac:spMkLst>
+            <pc:docMk/>
+            <pc:sldMk cId="0" sldId="291"/>
+            <ac:spMk id="4" creationId="{00000000-0000-0000-0000-000000000000}"/>
+          </ac:spMkLst>
+        </pc:spChg>
+        <pc:spChg chg="mod">
+          <ac:chgData name="KARTIK JADHAV B1-2620" userId="31dafa177a7777d4" providerId="LiveId" clId="{381810DB-81FF-485E-B53B-9CA04A6EA75A}" dt="2026-08-29T14:45:52.294" v="2" actId="255"/>
+          <ac:spMkLst>
+            <pc:docMk/>
+            <pc:sldMk cId="0" sldId="291"/>
+            <ac:spMk id="10" creationId="{00000000-0000-0000-0000-000000000000}"/>
+          </ac:spMkLst>
+        </pc:spChg>
+      </pc:sldChg>
+      <pc:sldChg chg="addSp delSp modSp mod">
+        <pc:chgData name="KARTIK JADHAV B1-2620" userId="31dafa177a7777d4" providerId="LiveId" clId="{381810DB-81FF-485E-B53B-9CA04A6EA75A}" dt="2026-08-29T14:55:56.454" v="53" actId="255"/>
+        <pc:sldMkLst>
+          <pc:docMk/>
+          <pc:sldMk cId="3753387913" sldId="293"/>
+        </pc:sldMkLst>
+        <pc:spChg chg="add del">
+          <ac:chgData name="KARTIK JADHAV B1-2620" userId="31dafa177a7777d4" providerId="LiveId" clId="{381810DB-81FF-485E-B53B-9CA04A6EA75A}" dt="2026-08-29T14:53:51.109" v="44" actId="478"/>
+          <ac:spMkLst>
+            <pc:docMk/>
+            <pc:sldMk cId="3753387913" sldId="293"/>
+            <ac:spMk id="7" creationId="{00000000-0000-0000-0000-000000000000}"/>
+          </ac:spMkLst>
+        </pc:spChg>
+        <pc:spChg chg="del mod">
+          <ac:chgData name="KARTIK JADHAV B1-2620" userId="31dafa177a7777d4" providerId="LiveId" clId="{381810DB-81FF-485E-B53B-9CA04A6EA75A}" dt="2026-08-29T14:53:41.434" v="40" actId="478"/>
+          <ac:spMkLst>
+            <pc:docMk/>
+            <pc:sldMk cId="3753387913" sldId="293"/>
+            <ac:spMk id="10" creationId="{AD4F69D3-EEB0-4C4C-9434-B9960FB5854C}"/>
+          </ac:spMkLst>
+        </pc:spChg>
+        <pc:spChg chg="mod">
+          <ac:chgData name="KARTIK JADHAV B1-2620" userId="31dafa177a7777d4" providerId="LiveId" clId="{381810DB-81FF-485E-B53B-9CA04A6EA75A}" dt="2026-08-29T14:55:10.379" v="49" actId="255"/>
+          <ac:spMkLst>
+            <pc:docMk/>
+            <pc:sldMk cId="3753387913" sldId="293"/>
+            <ac:spMk id="17410" creationId="{00000000-0000-0000-0000-000000000000}"/>
+          </ac:spMkLst>
+        </pc:spChg>
+        <pc:spChg chg="mod">
+          <ac:chgData name="KARTIK JADHAV B1-2620" userId="31dafa177a7777d4" providerId="LiveId" clId="{381810DB-81FF-485E-B53B-9CA04A6EA75A}" dt="2026-08-29T14:55:23.870" v="50" actId="255"/>
+          <ac:spMkLst>
+            <pc:docMk/>
+            <pc:sldMk cId="3753387913" sldId="293"/>
+            <ac:spMk id="17411" creationId="{00000000-0000-0000-0000-000000000000}"/>
+          </ac:spMkLst>
+        </pc:spChg>
+        <pc:spChg chg="mod">
+          <ac:chgData name="KARTIK JADHAV B1-2620" userId="31dafa177a7777d4" providerId="LiveId" clId="{381810DB-81FF-485E-B53B-9CA04A6EA75A}" dt="2026-08-29T14:55:34.405" v="51" actId="255"/>
+          <ac:spMkLst>
+            <pc:docMk/>
+            <pc:sldMk cId="3753387913" sldId="293"/>
+            <ac:spMk id="17413" creationId="{00000000-0000-0000-0000-000000000000}"/>
+          </ac:spMkLst>
+        </pc:spChg>
+        <pc:spChg chg="mod">
+          <ac:chgData name="KARTIK JADHAV B1-2620" userId="31dafa177a7777d4" providerId="LiveId" clId="{381810DB-81FF-485E-B53B-9CA04A6EA75A}" dt="2026-08-29T14:55:46.533" v="52" actId="255"/>
+          <ac:spMkLst>
+            <pc:docMk/>
+            <pc:sldMk cId="3753387913" sldId="293"/>
+            <ac:spMk id="17415" creationId="{00000000-0000-0000-0000-000000000000}"/>
+          </ac:spMkLst>
+        </pc:spChg>
+        <pc:spChg chg="mod">
+          <ac:chgData name="KARTIK JADHAV B1-2620" userId="31dafa177a7777d4" providerId="LiveId" clId="{381810DB-81FF-485E-B53B-9CA04A6EA75A}" dt="2026-08-29T14:55:56.454" v="53" actId="255"/>
+          <ac:spMkLst>
+            <pc:docMk/>
+            <pc:sldMk cId="3753387913" sldId="293"/>
+            <ac:spMk id="17417" creationId="{00000000-0000-0000-0000-000000000000}"/>
+          </ac:spMkLst>
+        </pc:spChg>
+      </pc:sldChg>
+      <pc:sldChg chg="addSp delSp modSp mod">
+        <pc:chgData name="KARTIK JADHAV B1-2620" userId="31dafa177a7777d4" providerId="LiveId" clId="{381810DB-81FF-485E-B53B-9CA04A6EA75A}" dt="2026-08-29T14:59:39.985" v="114" actId="255"/>
+        <pc:sldMkLst>
+          <pc:docMk/>
+          <pc:sldMk cId="2997144140" sldId="294"/>
+        </pc:sldMkLst>
+        <pc:spChg chg="add del mod">
+          <ac:chgData name="KARTIK JADHAV B1-2620" userId="31dafa177a7777d4" providerId="LiveId" clId="{381810DB-81FF-485E-B53B-9CA04A6EA75A}" dt="2026-08-29T14:58:38.512" v="106" actId="6549"/>
+          <ac:spMkLst>
+            <pc:docMk/>
+            <pc:sldMk cId="2997144140" sldId="294"/>
+            <ac:spMk id="7" creationId="{00000000-0000-0000-0000-000000000000}"/>
+          </ac:spMkLst>
+        </pc:spChg>
+        <pc:spChg chg="add del mod">
+          <ac:chgData name="KARTIK JADHAV B1-2620" userId="31dafa177a7777d4" providerId="LiveId" clId="{381810DB-81FF-485E-B53B-9CA04A6EA75A}" dt="2026-08-29T14:58:51.908" v="109" actId="478"/>
+          <ac:spMkLst>
+            <pc:docMk/>
+            <pc:sldMk cId="2997144140" sldId="294"/>
+            <ac:spMk id="10" creationId="{AD4F69D3-EEB0-4C4C-9434-B9960FB5854C}"/>
+          </ac:spMkLst>
+        </pc:spChg>
+        <pc:spChg chg="mod">
+          <ac:chgData name="KARTIK JADHAV B1-2620" userId="31dafa177a7777d4" providerId="LiveId" clId="{381810DB-81FF-485E-B53B-9CA04A6EA75A}" dt="2026-08-29T14:59:01.634" v="110" actId="255"/>
+          <ac:spMkLst>
+            <pc:docMk/>
+            <pc:sldMk cId="2997144140" sldId="294"/>
+            <ac:spMk id="17410" creationId="{00000000-0000-0000-0000-000000000000}"/>
+          </ac:spMkLst>
+        </pc:spChg>
+        <pc:spChg chg="mod">
+          <ac:chgData name="KARTIK JADHAV B1-2620" userId="31dafa177a7777d4" providerId="LiveId" clId="{381810DB-81FF-485E-B53B-9CA04A6EA75A}" dt="2026-08-29T14:59:12.819" v="111" actId="255"/>
+          <ac:spMkLst>
+            <pc:docMk/>
+            <pc:sldMk cId="2997144140" sldId="294"/>
+            <ac:spMk id="17411" creationId="{00000000-0000-0000-0000-000000000000}"/>
+          </ac:spMkLst>
+        </pc:spChg>
+        <pc:spChg chg="mod">
+          <ac:chgData name="KARTIK JADHAV B1-2620" userId="31dafa177a7777d4" providerId="LiveId" clId="{381810DB-81FF-485E-B53B-9CA04A6EA75A}" dt="2026-08-29T14:59:23.003" v="112" actId="255"/>
+          <ac:spMkLst>
+            <pc:docMk/>
+            <pc:sldMk cId="2997144140" sldId="294"/>
+            <ac:spMk id="17412" creationId="{00000000-0000-0000-0000-000000000000}"/>
+          </ac:spMkLst>
+        </pc:spChg>
+        <pc:spChg chg="mod">
+          <ac:chgData name="KARTIK JADHAV B1-2620" userId="31dafa177a7777d4" providerId="LiveId" clId="{381810DB-81FF-485E-B53B-9CA04A6EA75A}" dt="2026-08-29T14:59:31.694" v="113" actId="255"/>
+          <ac:spMkLst>
+            <pc:docMk/>
+            <pc:sldMk cId="2997144140" sldId="294"/>
+            <ac:spMk id="17413" creationId="{00000000-0000-0000-0000-000000000000}"/>
+          </ac:spMkLst>
+        </pc:spChg>
+        <pc:spChg chg="mod">
+          <ac:chgData name="KARTIK JADHAV B1-2620" userId="31dafa177a7777d4" providerId="LiveId" clId="{381810DB-81FF-485E-B53B-9CA04A6EA75A}" dt="2026-08-29T14:59:39.985" v="114" actId="255"/>
+          <ac:spMkLst>
+            <pc:docMk/>
+            <pc:sldMk cId="2997144140" sldId="294"/>
+            <ac:spMk id="17414" creationId="{00000000-0000-0000-0000-000000000000}"/>
+          </ac:spMkLst>
+        </pc:spChg>
+      </pc:sldChg>
+      <pc:sldChg chg="delSp modSp mod">
+        <pc:chgData name="KARTIK JADHAV B1-2620" userId="31dafa177a7777d4" providerId="LiveId" clId="{381810DB-81FF-485E-B53B-9CA04A6EA75A}" dt="2026-08-29T15:04:25.130" v="148" actId="255"/>
+        <pc:sldMkLst>
+          <pc:docMk/>
+          <pc:sldMk cId="3916788613" sldId="296"/>
+        </pc:sldMkLst>
+        <pc:spChg chg="del">
+          <ac:chgData name="KARTIK JADHAV B1-2620" userId="31dafa177a7777d4" providerId="LiveId" clId="{381810DB-81FF-485E-B53B-9CA04A6EA75A}" dt="2026-08-29T14:59:55.737" v="115" actId="478"/>
+          <ac:spMkLst>
+            <pc:docMk/>
+            <pc:sldMk cId="3916788613" sldId="296"/>
+            <ac:spMk id="10" creationId="{AD4F69D3-EEB0-4C4C-9434-B9960FB5854C}"/>
+          </ac:spMkLst>
+        </pc:spChg>
+        <pc:spChg chg="mod">
+          <ac:chgData name="KARTIK JADHAV B1-2620" userId="31dafa177a7777d4" providerId="LiveId" clId="{381810DB-81FF-485E-B53B-9CA04A6EA75A}" dt="2026-08-29T15:03:38.092" v="143" actId="6549"/>
+          <ac:spMkLst>
+            <pc:docMk/>
+            <pc:sldMk cId="3916788613" sldId="296"/>
+            <ac:spMk id="17410" creationId="{00000000-0000-0000-0000-000000000000}"/>
+          </ac:spMkLst>
+        </pc:spChg>
+        <pc:spChg chg="mod">
+          <ac:chgData name="KARTIK JADHAV B1-2620" userId="31dafa177a7777d4" providerId="LiveId" clId="{381810DB-81FF-485E-B53B-9CA04A6EA75A}" dt="2026-08-29T15:03:49.197" v="144" actId="255"/>
+          <ac:spMkLst>
+            <pc:docMk/>
+            <pc:sldMk cId="3916788613" sldId="296"/>
+            <ac:spMk id="17411" creationId="{00000000-0000-0000-0000-000000000000}"/>
+          </ac:spMkLst>
+        </pc:spChg>
+        <pc:spChg chg="mod">
+          <ac:chgData name="KARTIK JADHAV B1-2620" userId="31dafa177a7777d4" providerId="LiveId" clId="{381810DB-81FF-485E-B53B-9CA04A6EA75A}" dt="2026-08-29T15:03:58.532" v="145" actId="255"/>
+          <ac:spMkLst>
+            <pc:docMk/>
+            <pc:sldMk cId="3916788613" sldId="296"/>
+            <ac:spMk id="17412" creationId="{00000000-0000-0000-0000-000000000000}"/>
+          </ac:spMkLst>
+        </pc:spChg>
+        <pc:spChg chg="mod">
+          <ac:chgData name="KARTIK JADHAV B1-2620" userId="31dafa177a7777d4" providerId="LiveId" clId="{381810DB-81FF-485E-B53B-9CA04A6EA75A}" dt="2026-08-29T15:04:08.520" v="146" actId="255"/>
+          <ac:spMkLst>
+            <pc:docMk/>
+            <pc:sldMk cId="3916788613" sldId="296"/>
+            <ac:spMk id="17413" creationId="{00000000-0000-0000-0000-000000000000}"/>
+          </ac:spMkLst>
+        </pc:spChg>
+        <pc:spChg chg="mod">
+          <ac:chgData name="KARTIK JADHAV B1-2620" userId="31dafa177a7777d4" providerId="LiveId" clId="{381810DB-81FF-485E-B53B-9CA04A6EA75A}" dt="2026-08-29T15:04:18.187" v="147" actId="255"/>
+          <ac:spMkLst>
+            <pc:docMk/>
+            <pc:sldMk cId="3916788613" sldId="296"/>
+            <ac:spMk id="17414" creationId="{00000000-0000-0000-0000-000000000000}"/>
+          </ac:spMkLst>
+        </pc:spChg>
+        <pc:spChg chg="mod">
+          <ac:chgData name="KARTIK JADHAV B1-2620" userId="31dafa177a7777d4" providerId="LiveId" clId="{381810DB-81FF-485E-B53B-9CA04A6EA75A}" dt="2026-08-29T15:04:25.130" v="148" actId="255"/>
+          <ac:spMkLst>
+            <pc:docMk/>
+            <pc:sldMk cId="3916788613" sldId="296"/>
+            <ac:spMk id="17415" creationId="{00000000-0000-0000-0000-000000000000}"/>
+          </ac:spMkLst>
+        </pc:spChg>
+      </pc:sldChg>
+    </pc:docChg>
+  </pc:docChgLst>
+</pc:chgInfo>
+</file>
+
 <file path=ppt/notesMasters/notesMaster1.xml><?xml version="1.0" encoding="utf-8"?>
 <p:notesMaster xmlns:a="http://schemas.openxmlformats.org/drawingml/2006/main" xmlns:r="http://schemas.openxmlformats.org/officeDocument/2006/relationships" xmlns:p="http://schemas.openxmlformats.org/presentationml/2006/main">
   <p:cSld>
@@ -261,7 +645,7 @@
             <a:fld id="{C4D5ADD5-2BBC-4A94-8F86-D9013941F742}" type="datetimeFigureOut">
               <a:rPr lang="en-US"/>
               <a:pPr/>
-              <a:t>6/2/2026</a:t>
+              <a:t>8/29/2026</a:t>
             </a:fld>
             <a:endParaRPr lang="en-US"/>
           </a:p>
@@ -1351,184 +1735,6 @@
 </p:notes>
 </file>
 
-<file path=ppt/notesSlides/notesSlide6.xml><?xml version="1.0" encoding="utf-8"?>
-<p:notes xmlns:a="http://schemas.openxmlformats.org/drawingml/2006/main" xmlns:r="http://schemas.openxmlformats.org/officeDocument/2006/relationships" xmlns:p="http://schemas.openxmlformats.org/presentationml/2006/main">
-  <p:cSld>
-    <p:spTree>
-      <p:nvGrpSpPr>
-        <p:cNvPr id="1" name=""/>
-        <p:cNvGrpSpPr/>
-        <p:nvPr/>
-      </p:nvGrpSpPr>
-      <p:grpSpPr>
-        <a:xfrm>
-          <a:off x="0" y="0"/>
-          <a:ext cx="0" cy="0"/>
-          <a:chOff x="0" y="0"/>
-          <a:chExt cx="0" cy="0"/>
-        </a:xfrm>
-      </p:grpSpPr>
-      <p:sp>
-        <p:nvSpPr>
-          <p:cNvPr id="18433" name="Slide Image Placeholder 1"/>
-          <p:cNvSpPr>
-            <a:spLocks noGrp="1" noRot="1" noChangeAspect="1"/>
-          </p:cNvSpPr>
-          <p:nvPr>
-            <p:ph type="sldImg"/>
-          </p:nvPr>
-        </p:nvSpPr>
-        <p:spPr bwMode="auto">
-          <a:xfrm>
-            <a:off x="381000" y="685800"/>
-            <a:ext cx="6096000" cy="3429000"/>
-          </a:xfrm>
-          <a:noFill/>
-          <a:ln>
-            <a:solidFill>
-              <a:srgbClr val="000000"/>
-            </a:solidFill>
-            <a:miter lim="800000"/>
-            <a:headEnd/>
-            <a:tailEnd/>
-          </a:ln>
-        </p:spPr>
-      </p:sp>
-      <p:sp>
-        <p:nvSpPr>
-          <p:cNvPr id="18434" name="Notes Placeholder 2"/>
-          <p:cNvSpPr>
-            <a:spLocks noGrp="1"/>
-          </p:cNvSpPr>
-          <p:nvPr>
-            <p:ph type="body" idx="1"/>
-          </p:nvPr>
-        </p:nvSpPr>
-        <p:spPr bwMode="auto">
-          <a:noFill/>
-        </p:spPr>
-        <p:txBody>
-          <a:bodyPr wrap="square" numCol="1" anchor="t" anchorCtr="0" compatLnSpc="1">
-            <a:prstTxWarp prst="textNoShape">
-              <a:avLst/>
-            </a:prstTxWarp>
-          </a:bodyPr>
-          <a:lstStyle/>
-          <a:p>
-            <a:pPr eaLnBrk="1" hangingPunct="1">
-              <a:spcBef>
-                <a:spcPct val="0"/>
-              </a:spcBef>
-            </a:pPr>
-            <a:endParaRPr lang="en-US">
-              <a:ea typeface="ＭＳ Ｐゴシック" pitchFamily="1" charset="-128"/>
-            </a:endParaRPr>
-          </a:p>
-        </p:txBody>
-      </p:sp>
-      <p:sp>
-        <p:nvSpPr>
-          <p:cNvPr id="18435" name="Slide Number Placeholder 3"/>
-          <p:cNvSpPr>
-            <a:spLocks noGrp="1"/>
-          </p:cNvSpPr>
-          <p:nvPr>
-            <p:ph type="sldNum" sz="quarter" idx="5"/>
-          </p:nvPr>
-        </p:nvSpPr>
-        <p:spPr bwMode="auto">
-          <a:noFill/>
-          <a:ln>
-            <a:miter lim="800000"/>
-            <a:headEnd/>
-            <a:tailEnd/>
-          </a:ln>
-        </p:spPr>
-        <p:txBody>
-          <a:bodyPr/>
-          <a:lstStyle/>
-          <a:p>
-            <a:pPr marL="0" marR="0" lvl="0" indent="0" algn="r" defTabSz="457200" rtl="0" eaLnBrk="1" fontAlgn="base" latinLnBrk="0" hangingPunct="1">
-              <a:lnSpc>
-                <a:spcPct val="100000"/>
-              </a:lnSpc>
-              <a:spcBef>
-                <a:spcPct val="0"/>
-              </a:spcBef>
-              <a:spcAft>
-                <a:spcPct val="0"/>
-              </a:spcAft>
-              <a:buClrTx/>
-              <a:buSzTx/>
-              <a:buFontTx/>
-              <a:buNone/>
-              <a:tabLst/>
-              <a:defRPr/>
-            </a:pPr>
-            <a:fld id="{0CA7B74D-3791-4AC6-8451-F10DBCCCDD9A}" type="slidenum">
-              <a:rPr kumimoji="0" lang="en-US" sz="1200" b="0" i="0" u="none" strike="noStrike" kern="1200" cap="none" spc="0" normalizeH="0" baseline="0" noProof="0">
-                <a:ln>
-                  <a:noFill/>
-                </a:ln>
-                <a:solidFill>
-                  <a:prstClr val="black"/>
-                </a:solidFill>
-                <a:effectLst/>
-                <a:uLnTx/>
-                <a:uFillTx/>
-                <a:latin typeface="Calibri" pitchFamily="34" charset="0"/>
-                <a:ea typeface="ＭＳ Ｐゴシック" pitchFamily="1" charset="-128"/>
-                <a:cs typeface="+mn-cs"/>
-              </a:rPr>
-              <a:pPr marL="0" marR="0" lvl="0" indent="0" algn="r" defTabSz="457200" rtl="0" eaLnBrk="1" fontAlgn="base" latinLnBrk="0" hangingPunct="1">
-                <a:lnSpc>
-                  <a:spcPct val="100000"/>
-                </a:lnSpc>
-                <a:spcBef>
-                  <a:spcPct val="0"/>
-                </a:spcBef>
-                <a:spcAft>
-                  <a:spcPct val="0"/>
-                </a:spcAft>
-                <a:buClrTx/>
-                <a:buSzTx/>
-                <a:buFontTx/>
-                <a:buNone/>
-                <a:tabLst/>
-                <a:defRPr/>
-              </a:pPr>
-              <a:t>7</a:t>
-            </a:fld>
-            <a:endParaRPr kumimoji="0" lang="en-US" sz="1200" b="0" i="0" u="none" strike="noStrike" kern="1200" cap="none" spc="0" normalizeH="0" baseline="0" noProof="0">
-              <a:ln>
-                <a:noFill/>
-              </a:ln>
-              <a:solidFill>
-                <a:prstClr val="black"/>
-              </a:solidFill>
-              <a:effectLst/>
-              <a:uLnTx/>
-              <a:uFillTx/>
-              <a:latin typeface="Calibri" pitchFamily="34" charset="0"/>
-              <a:ea typeface="ＭＳ Ｐゴシック" pitchFamily="1" charset="-128"/>
-              <a:cs typeface="+mn-cs"/>
-            </a:endParaRPr>
-          </a:p>
-        </p:txBody>
-      </p:sp>
-    </p:spTree>
-    <p:extLst>
-      <p:ext uri="{BB962C8B-B14F-4D97-AF65-F5344CB8AC3E}">
-        <p14:creationId xmlns:p14="http://schemas.microsoft.com/office/powerpoint/2010/main" val="3783576877"/>
-      </p:ext>
-    </p:extLst>
-  </p:cSld>
-  <p:clrMapOvr>
-    <a:masterClrMapping/>
-  </p:clrMapOvr>
-</p:notes>
-</file>
-
 <file path=ppt/slideLayouts/slideLayout1.xml><?xml version="1.0" encoding="utf-8"?>
 <p:sldLayout xmlns:a="http://schemas.openxmlformats.org/drawingml/2006/main" xmlns:r="http://schemas.openxmlformats.org/officeDocument/2006/relationships" xmlns:p="http://schemas.openxmlformats.org/presentationml/2006/main" type="title" preserve="1">
   <p:cSld name="Title Slide">
@@ -1712,7 +1918,7 @@
           <a:p>
             <a:fld id="{E60792E3-D524-454C-8AFD-A91972900BCB}" type="datetime1">
               <a:rPr lang="en-US" smtClean="0"/>
-              <a:t>6/2/2026</a:t>
+              <a:t>8/29/2026</a:t>
             </a:fld>
             <a:endParaRPr lang="en-US"/>
           </a:p>
@@ -1894,7 +2100,7 @@
           <a:p>
             <a:fld id="{053C3A68-6922-42D3-8905-ECC2D82A3469}" type="datetime1">
               <a:rPr lang="en-US" smtClean="0"/>
-              <a:t>6/2/2026</a:t>
+              <a:t>8/29/2026</a:t>
             </a:fld>
             <a:endParaRPr lang="en-US"/>
           </a:p>
@@ -2086,7 +2292,7 @@
           <a:p>
             <a:fld id="{CB69E9F4-7604-4950-A8B2-8ACDEDB1506E}" type="datetime1">
               <a:rPr lang="en-US" smtClean="0"/>
-              <a:t>6/2/2026</a:t>
+              <a:t>8/29/2026</a:t>
             </a:fld>
             <a:endParaRPr lang="en-US"/>
           </a:p>
@@ -2268,7 +2474,7 @@
           <a:p>
             <a:fld id="{708B7524-32A2-4C20-A58C-BC3BAA1042FC}" type="datetime1">
               <a:rPr lang="en-US" smtClean="0"/>
-              <a:t>6/2/2026</a:t>
+              <a:t>8/29/2026</a:t>
             </a:fld>
             <a:endParaRPr lang="en-US"/>
           </a:p>
@@ -2527,7 +2733,7 @@
           <a:p>
             <a:fld id="{1E994447-D6B2-43BB-A877-57F1A267B999}" type="datetime1">
               <a:rPr lang="en-US" smtClean="0"/>
-              <a:t>6/2/2026</a:t>
+              <a:t>8/29/2026</a:t>
             </a:fld>
             <a:endParaRPr lang="en-US"/>
           </a:p>
@@ -2826,7 +3032,7 @@
           <a:p>
             <a:fld id="{68920E16-BD35-483C-AA6B-346FC7E46DEA}" type="datetime1">
               <a:rPr lang="en-US" smtClean="0"/>
-              <a:t>6/2/2026</a:t>
+              <a:t>8/29/2026</a:t>
             </a:fld>
             <a:endParaRPr lang="en-US"/>
           </a:p>
@@ -3259,7 +3465,7 @@
           <a:p>
             <a:fld id="{2FEAC6F8-5103-4FC0-A69E-5C6AE6469DA8}" type="datetime1">
               <a:rPr lang="en-US" smtClean="0"/>
-              <a:t>6/2/2026</a:t>
+              <a:t>8/29/2026</a:t>
             </a:fld>
             <a:endParaRPr lang="en-US"/>
           </a:p>
@@ -3390,7 +3596,7 @@
           <a:p>
             <a:fld id="{C60C6921-0627-4C8F-83D5-0CF936D2FFDD}" type="datetime1">
               <a:rPr lang="en-US" smtClean="0"/>
-              <a:t>6/2/2026</a:t>
+              <a:t>8/29/2026</a:t>
             </a:fld>
             <a:endParaRPr lang="en-US"/>
           </a:p>
@@ -3499,7 +3705,7 @@
           <a:p>
             <a:fld id="{2FF08AD7-8103-40F8-983C-E2BA6BB9CBE0}" type="datetime1">
               <a:rPr lang="en-US" smtClean="0"/>
-              <a:t>6/2/2026</a:t>
+              <a:t>8/29/2026</a:t>
             </a:fld>
             <a:endParaRPr lang="en-US"/>
           </a:p>
@@ -3788,7 +3994,7 @@
           <a:p>
             <a:fld id="{DF8C06B4-9380-4A4D-AF49-A3596E17DAF5}" type="datetime1">
               <a:rPr lang="en-US" smtClean="0"/>
-              <a:t>6/2/2026</a:t>
+              <a:t>8/29/2026</a:t>
             </a:fld>
             <a:endParaRPr lang="en-US"/>
           </a:p>
@@ -4057,7 +4263,7 @@
           <a:p>
             <a:fld id="{EF7FDEF1-C582-4E22-9E77-D68326471F28}" type="datetime1">
               <a:rPr lang="en-US" smtClean="0"/>
-              <a:t>6/2/2026</a:t>
+              <a:t>8/29/2026</a:t>
             </a:fld>
             <a:endParaRPr lang="en-US"/>
           </a:p>
@@ -4300,7 +4506,7 @@
           <a:p>
             <a:fld id="{780A9602-A9A9-453F-AEF1-37B5837E02CD}" type="datetime1">
               <a:rPr lang="en-US" smtClean="0"/>
-              <a:t>6/2/2026</a:t>
+              <a:t>8/29/2026</a:t>
             </a:fld>
             <a:endParaRPr lang="en-US"/>
           </a:p>
@@ -4851,7 +5057,7 @@
                 <a16:creationId xmlns:a16="http://schemas.microsoft.com/office/drawing/2014/main" id="{3E443FD7-A66B-4AA0-872D-B088B9BC5F17}"/>
               </a:ext>
               <a:ext uri="{C183D7F6-B498-43B3-948B-1728B52AA6E4}">
-                <adec:decorative xmlns:adec="http://schemas.microsoft.com/office/drawing/2017/decorative" xmlns="" val="1"/>
+                <adec:decorative xmlns:adec="http://schemas.microsoft.com/office/drawing/2017/decorative" val="1"/>
               </a:ext>
             </a:extLst>
           </p:cNvPr>
@@ -4911,7 +5117,7 @@
                 <a16:creationId xmlns:a16="http://schemas.microsoft.com/office/drawing/2014/main" id="{C04BE0EF-3561-49B4-9A29-F283168A91C7}"/>
               </a:ext>
               <a:ext uri="{C183D7F6-B498-43B3-948B-1728B52AA6E4}">
-                <adec:decorative xmlns:adec="http://schemas.microsoft.com/office/drawing/2017/decorative" xmlns="" val="1"/>
+                <adec:decorative xmlns:adec="http://schemas.microsoft.com/office/drawing/2017/decorative" val="1"/>
               </a:ext>
             </a:extLst>
           </p:cNvPr>
@@ -5730,7 +5936,7 @@
               <a:buNone/>
             </a:pPr>
             <a:r>
-              <a:rPr sz="3200" b="1">
+              <a:rPr sz="3200" b="1" dirty="0">
                 <a:solidFill>
                   <a:srgbClr val="0A2350"/>
                 </a:solidFill>
@@ -5750,12 +5956,20 @@
               <a:buNone/>
             </a:pPr>
             <a:r>
-              <a:rPr sz="1300" b="1">
+              <a:rPr sz="1300" b="1" dirty="0">
                 <a:solidFill>
                   <a:srgbClr val="1E82BE"/>
                 </a:solidFill>
               </a:rPr>
-              <a:t>India's Politician Accountability &amp; Civic Intelligence Platform</a:t>
+              <a:t>In</a:t>
+            </a:r>
+            <a:r>
+              <a:rPr sz="1400" b="1" dirty="0">
+                <a:solidFill>
+                  <a:srgbClr val="1E82BE"/>
+                </a:solidFill>
+              </a:rPr>
+              <a:t>dia's Politician Accountability &amp; Civic Intelligence Platform</a:t>
             </a:r>
           </a:p>
           <a:p>
@@ -5763,7 +5977,7 @@
               <a:buNone/>
             </a:pPr>
             <a:r>
-              <a:rPr sz="1100" b="0">
+              <a:rPr sz="1400" b="0" dirty="0">
                 <a:solidFill>
                   <a:srgbClr val="2D2D2D"/>
                 </a:solidFill>
@@ -5800,16 +6014,7 @@
                 </a:solidFill>
                 <a:latin typeface="Garamond" panose="02020404030301010803" pitchFamily="18" charset="0"/>
               </a:rPr>
-              <a:t>SMART INDIA HACKATHON </a:t>
-            </a:r>
-            <a:r>
-              <a:rPr lang="en-US" sz="4000" b="1" dirty="0" smtClean="0">
-                <a:solidFill>
-                  <a:schemeClr val="tx2"/>
-                </a:solidFill>
-                <a:latin typeface="Garamond" panose="02020404030301010803" pitchFamily="18" charset="0"/>
-              </a:rPr>
-              <a:t>2026</a:t>
+              <a:t>SMART INDIA HACKATHON 2026</a:t>
             </a:r>
             <a:endParaRPr lang="en-IN" sz="4000" b="1" dirty="0">
               <a:solidFill>
@@ -5828,8 +6033,8 @@
         </p:nvSpPr>
         <p:spPr>
           <a:xfrm>
-            <a:off x="331286" y="2076450"/>
-            <a:ext cx="5924550" cy="4703019"/>
+            <a:off x="473141" y="2153490"/>
+            <a:ext cx="5924550" cy="2939266"/>
           </a:xfrm>
           <a:prstGeom prst="rect">
             <a:avLst/>
@@ -5849,7 +6054,7 @@
               <a:buNone/>
             </a:pPr>
             <a:r>
-              <a:rPr sz="1100" b="1">
+              <a:rPr sz="2000" b="1" dirty="0">
                 <a:solidFill>
                   <a:srgbClr val="2D2D2D"/>
                 </a:solidFill>
@@ -5857,14 +6062,14 @@
               <a:t>Problem Statement ID: </a:t>
             </a:r>
             <a:r>
-              <a:rPr sz="1100" b="1">
+              <a:rPr sz="2000" b="1" dirty="0">
                 <a:solidFill>
                   <a:srgbClr val="003C82"/>
                 </a:solidFill>
               </a:rPr>
               <a:t>SIH26102</a:t>
             </a:r>
-            <a:endParaRPr lang="en-US" dirty="0"/>
+            <a:endParaRPr lang="en-US" sz="2000" dirty="0"/>
           </a:p>
           <a:p>
             <a:pPr>
@@ -5874,7 +6079,7 @@
               <a:buNone/>
             </a:pPr>
             <a:r>
-              <a:rPr sz="1100" b="1">
+              <a:rPr sz="2000" b="1" dirty="0">
                 <a:solidFill>
                   <a:srgbClr val="2D2D2D"/>
                 </a:solidFill>
@@ -5882,7 +6087,7 @@
               <a:t>Problem Statement Title: </a:t>
             </a:r>
             <a:r>
-              <a:rPr sz="1100" b="1">
+              <a:rPr sz="2000" b="1" dirty="0">
                 <a:solidFill>
                   <a:srgbClr val="003C82"/>
                 </a:solidFill>
@@ -5898,7 +6103,7 @@
               <a:buNone/>
             </a:pPr>
             <a:r>
-              <a:rPr sz="1100" b="1">
+              <a:rPr sz="2000" b="1" dirty="0">
                 <a:solidFill>
                   <a:srgbClr val="2D2D2D"/>
                 </a:solidFill>
@@ -5906,7 +6111,7 @@
               <a:t>Theme: </a:t>
             </a:r>
             <a:r>
-              <a:rPr sz="1100" b="0">
+              <a:rPr sz="2000" b="0" dirty="0">
                 <a:solidFill>
                   <a:srgbClr val="2D2D2D"/>
                 </a:solidFill>
@@ -5922,7 +6127,7 @@
               <a:buNone/>
             </a:pPr>
             <a:r>
-              <a:rPr sz="1100" b="1">
+              <a:rPr sz="2000" b="1" dirty="0">
                 <a:solidFill>
                   <a:srgbClr val="2D2D2D"/>
                 </a:solidFill>
@@ -5930,7 +6135,7 @@
               <a:t>PS Category: </a:t>
             </a:r>
             <a:r>
-              <a:rPr sz="1100" b="0">
+              <a:rPr sz="2000" b="0" dirty="0">
                 <a:solidFill>
                   <a:srgbClr val="2D2D2D"/>
                 </a:solidFill>
@@ -5946,7 +6151,7 @@
               <a:buNone/>
             </a:pPr>
             <a:r>
-              <a:rPr sz="1100" b="1">
+              <a:rPr sz="2000" b="1" dirty="0">
                 <a:solidFill>
                   <a:srgbClr val="2D2D2D"/>
                 </a:solidFill>
@@ -5954,7 +6159,7 @@
               <a:t>Team ID: </a:t>
             </a:r>
             <a:r>
-              <a:rPr sz="1100" b="1">
+              <a:rPr sz="2000" b="1" dirty="0">
                 <a:solidFill>
                   <a:srgbClr val="003C82"/>
                 </a:solidFill>
@@ -5970,7 +6175,7 @@
               <a:buNone/>
             </a:pPr>
             <a:r>
-              <a:rPr sz="1100" b="1">
+              <a:rPr sz="2000" b="1" dirty="0">
                 <a:solidFill>
                   <a:srgbClr val="2D2D2D"/>
                 </a:solidFill>
@@ -5978,36 +6183,12 @@
               <a:t>Team Name: </a:t>
             </a:r>
             <a:r>
-              <a:rPr sz="1100" b="1">
+              <a:rPr sz="2000" b="1" dirty="0">
                 <a:solidFill>
                   <a:srgbClr val="003C82"/>
                 </a:solidFill>
               </a:rPr>
               <a:t>VERDICT</a:t>
-            </a:r>
-          </a:p>
-          <a:p>
-            <a:pPr>
-              <a:spcAft>
-                <a:spcPts val="600"/>
-              </a:spcAft>
-              <a:buNone/>
-            </a:pPr>
-            <a:r>
-              <a:rPr sz="1100" b="1">
-                <a:solidFill>
-                  <a:srgbClr val="2D2D2D"/>
-                </a:solidFill>
-              </a:rPr>
-              <a:t>Live Platform: </a:t>
-            </a:r>
-            <a:r>
-              <a:rPr sz="1100" b="1">
-                <a:solidFill>
-                  <a:srgbClr val="008C4B"/>
-                </a:solidFill>
-              </a:rPr>
-              <a:t>https://verdict.vercel.app</a:t>
             </a:r>
           </a:p>
         </p:txBody>
@@ -6069,64 +6250,6 @@
       </p:grpSpPr>
       <p:sp>
         <p:nvSpPr>
-          <p:cNvPr id="9" name="Rectangle 8"/>
-          <p:cNvSpPr>
-            <a:spLocks noChangeArrowheads="1"/>
-          </p:cNvSpPr>
-          <p:nvPr/>
-        </p:nvSpPr>
-        <p:spPr bwMode="auto">
-          <a:xfrm>
-            <a:off x="0" y="6354762"/>
-            <a:ext cx="12191999" cy="503238"/>
-          </a:xfrm>
-          <a:prstGeom prst="rect">
-            <a:avLst/>
-          </a:prstGeom>
-          <a:solidFill>
-            <a:srgbClr val="0070C0"/>
-          </a:solidFill>
-          <a:ln w="9525">
-            <a:noFill/>
-            <a:miter lim="800000"/>
-            <a:headEnd/>
-            <a:tailEnd/>
-          </a:ln>
-          <a:effectLst>
-            <a:outerShdw dist="23000" dir="5400000" rotWithShape="0">
-              <a:srgbClr val="808080">
-                <a:alpha val="34999"/>
-              </a:srgbClr>
-            </a:outerShdw>
-          </a:effectLst>
-        </p:spPr>
-        <p:txBody>
-          <a:bodyPr anchor="ctr"/>
-          <a:lstStyle/>
-          <a:p>
-            <a:pPr algn="ctr" fontAlgn="auto">
-              <a:spcBef>
-                <a:spcPts val="0"/>
-              </a:spcBef>
-              <a:spcAft>
-                <a:spcPts val="0"/>
-              </a:spcAft>
-              <a:defRPr/>
-            </a:pPr>
-            <a:endParaRPr lang="en-US" dirty="0">
-              <a:solidFill>
-                <a:schemeClr val="accent2">
-                  <a:lumMod val="75000"/>
-                </a:schemeClr>
-              </a:solidFill>
-              <a:latin typeface="+mn-lt"/>
-              <a:ea typeface="+mn-ea"/>
-            </a:endParaRPr>
-          </a:p>
-        </p:txBody>
-      </p:sp>
-      <p:sp>
-        <p:nvSpPr>
           <p:cNvPr id="15361" name="Title 1"/>
           <p:cNvSpPr>
             <a:spLocks noGrp="1"/>
@@ -6146,14 +6269,6 @@
           <a:lstStyle/>
           <a:p>
             <a:pPr eaLnBrk="1" hangingPunct="1"/>
-            <a:r>
-              <a:rPr lang="en-US" sz="3600" b="1" dirty="0">
-                <a:latin typeface="Times New Roman" panose="02020603050405020304" pitchFamily="18" charset="0"/>
-                <a:ea typeface="ＭＳ Ｐゴシック" pitchFamily="1" charset="-128"/>
-                <a:cs typeface="Times New Roman" panose="02020603050405020304" pitchFamily="18" charset="0"/>
-              </a:rPr>
-              <a:t/>
-            </a:r>
             <a:br>
               <a:rPr lang="en-US" sz="3600" b="1" dirty="0">
                 <a:latin typeface="Times New Roman" panose="02020603050405020304" pitchFamily="18" charset="0"/>
@@ -6182,8 +6297,8 @@
         </p:nvSpPr>
         <p:spPr bwMode="auto">
           <a:xfrm>
-            <a:off x="612648" y="1207008"/>
-            <a:ext cx="10972800" cy="3017520"/>
+            <a:off x="886968" y="1230096"/>
+            <a:ext cx="10972800" cy="3095206"/>
           </a:xfrm>
           <a:prstGeom prst="rect">
             <a:avLst/>
@@ -6197,7 +6312,7 @@
           </a:ln>
         </p:spPr>
         <p:txBody>
-          <a:bodyPr wrap="square" lIns="45720" rIns="45720" tIns="36576" bIns="36576">
+          <a:bodyPr wrap="square" lIns="45720" tIns="36576" rIns="45720" bIns="36576">
             <a:spAutoFit/>
           </a:bodyPr>
           <a:lstStyle/>
@@ -6212,14 +6327,14 @@
               <a:buNone/>
             </a:pPr>
             <a:r>
-              <a:rPr sz="1050" b="1">
+              <a:rPr sz="2000" b="1" dirty="0">
                 <a:solidFill>
                   <a:srgbClr val="C82D2D"/>
                 </a:solidFill>
               </a:rPr>
               <a:t>THE CRITICAL CITIZEN PROBLEM IN INDIA TODAY:</a:t>
             </a:r>
-            <a:endParaRPr lang="en-US" sz="3200" u="sng" dirty="0">
+            <a:endParaRPr lang="en-US" sz="2000" u="sng" dirty="0">
               <a:solidFill>
                 <a:schemeClr val="tx2"/>
               </a:solidFill>
@@ -6238,12 +6353,20 @@
               <a:buNone/>
             </a:pPr>
             <a:r>
-              <a:rPr sz="900" b="0">
-                <a:solidFill>
-                  <a:srgbClr val="2D2D2D"/>
-                </a:solidFill>
-              </a:rPr>
-              <a:t>  • Candidate criminal cases &amp; wealth records are locked inside 400-page scanned affidavits and complex legal terminology.</a:t>
+              <a:rPr sz="1700" b="0" dirty="0">
+                <a:solidFill>
+                  <a:srgbClr val="2D2D2D"/>
+                </a:solidFill>
+              </a:rPr>
+              <a:t>  </a:t>
+            </a:r>
+            <a:r>
+              <a:rPr sz="1600" b="0" dirty="0">
+                <a:solidFill>
+                  <a:srgbClr val="2D2D2D"/>
+                </a:solidFill>
+              </a:rPr>
+              <a:t>• Candidate criminal cases &amp; wealth records are locked inside 400-page scanned affidavits and complex legal terminology.</a:t>
             </a:r>
           </a:p>
           <a:p>
@@ -6257,7 +6380,7 @@
               <a:buNone/>
             </a:pPr>
             <a:r>
-              <a:rPr sz="900" b="0">
+              <a:rPr sz="1600" b="0" dirty="0">
                 <a:solidFill>
                   <a:srgbClr val="2D2D2D"/>
                 </a:solidFill>
@@ -6276,7 +6399,7 @@
               <a:buNone/>
             </a:pPr>
             <a:r>
-              <a:rPr sz="900" b="0">
+              <a:rPr sz="1600" b="0" dirty="0">
                 <a:solidFill>
                   <a:srgbClr val="2D2D2D"/>
                 </a:solidFill>
@@ -6294,8 +6417,24 @@
               </a:spcAft>
               <a:buNone/>
             </a:pPr>
-            <a:r>
-              <a:rPr sz="1050" b="1">
+            <a:endParaRPr lang="en-US" sz="1700" b="1" dirty="0">
+              <a:solidFill>
+                <a:srgbClr val="008C4B"/>
+              </a:solidFill>
+            </a:endParaRPr>
+          </a:p>
+          <a:p>
+            <a:pPr>
+              <a:spcBef>
+                <a:spcPts val="500"/>
+              </a:spcBef>
+              <a:spcAft>
+                <a:spcPts val="200"/>
+              </a:spcAft>
+              <a:buNone/>
+            </a:pPr>
+            <a:r>
+              <a:rPr sz="2000" b="1" dirty="0">
                 <a:solidFill>
                   <a:srgbClr val="008C4B"/>
                 </a:solidFill>
@@ -6314,7 +6453,7 @@
               <a:buNone/>
             </a:pPr>
             <a:r>
-              <a:rPr sz="900" b="0">
+              <a:rPr sz="1700" b="0" dirty="0">
                 <a:solidFill>
                   <a:srgbClr val="2D2D2D"/>
                 </a:solidFill>
@@ -6333,7 +6472,7 @@
               <a:buNone/>
             </a:pPr>
             <a:r>
-              <a:rPr sz="900" b="0">
+              <a:rPr sz="1700" b="0" dirty="0">
                 <a:solidFill>
                   <a:srgbClr val="2D2D2D"/>
                 </a:solidFill>
@@ -6352,7 +6491,7 @@
               <a:buNone/>
             </a:pPr>
             <a:r>
-              <a:rPr sz="900" b="0">
+              <a:rPr sz="1700" b="0" dirty="0">
                 <a:solidFill>
                   <a:srgbClr val="2D2D2D"/>
                 </a:solidFill>
@@ -6371,7 +6510,7 @@
               <a:buNone/>
             </a:pPr>
             <a:r>
-              <a:rPr sz="900" b="0">
+              <a:rPr sz="1700" b="0" dirty="0">
                 <a:solidFill>
                   <a:srgbClr val="2D2D2D"/>
                 </a:solidFill>
@@ -6437,18 +6576,13 @@
               <a:defRPr/>
             </a:pPr>
             <a:r>
-              <a:rPr lang="en-US">
+              <a:rPr lang="en-US" dirty="0">
                 <a:solidFill>
                   <a:schemeClr val="bg1"/>
                 </a:solidFill>
               </a:rPr>
               <a:t>@SIH Idea submission- Template</a:t>
             </a:r>
-            <a:endParaRPr lang="en-US" dirty="0">
-              <a:solidFill>
-                <a:schemeClr val="bg1"/>
-              </a:solidFill>
-            </a:endParaRPr>
           </a:p>
         </p:txBody>
       </p:sp>
@@ -6460,7 +6594,7 @@
                 <a16:creationId xmlns:a16="http://schemas.microsoft.com/office/drawing/2014/main" id="{5DBCE864-823D-4A13-9607-5DA1F0ED5FB8}"/>
               </a:ext>
               <a:ext uri="{C183D7F6-B498-43B3-948B-1728B52AA6E4}">
-                <adec:decorative xmlns:adec="http://schemas.microsoft.com/office/drawing/2017/decorative" xmlns="" val="0"/>
+                <adec:decorative xmlns:adec="http://schemas.microsoft.com/office/drawing/2017/decorative" val="0"/>
               </a:ext>
             </a:extLst>
           </p:cNvPr>
@@ -6555,7 +6689,7 @@
         </p:nvSpPr>
         <p:spPr>
           <a:xfrm>
-            <a:off x="612648" y="4343400"/>
+            <a:off x="612648" y="4782312"/>
             <a:ext cx="2240280" cy="1508760"/>
           </a:xfrm>
           <a:prstGeom prst="roundRect">
@@ -6585,7 +6719,7 @@
           </a:fontRef>
         </p:style>
         <p:txBody>
-          <a:bodyPr rtlCol="0" anchor="ctr" wrap="square" lIns="73152" rIns="73152" tIns="54864" bIns="54864"/>
+          <a:bodyPr wrap="square" lIns="73152" tIns="54864" rIns="73152" bIns="54864" rtlCol="0" anchor="ctr"/>
           <a:lstStyle/>
           <a:p>
             <a:pPr algn="ctr">
@@ -6595,7 +6729,7 @@
               <a:buNone/>
             </a:pPr>
             <a:r>
-              <a:rPr sz="950" b="1">
+              <a:rPr sz="1400" b="1" dirty="0">
                 <a:solidFill>
                   <a:srgbClr val="C82D2D"/>
                 </a:solidFill>
@@ -6611,7 +6745,7 @@
               <a:buNone/>
             </a:pPr>
             <a:r>
-              <a:rPr sz="800" b="0">
+              <a:rPr sz="1400" b="0" dirty="0">
                 <a:solidFill>
                   <a:srgbClr val="2D2D2D"/>
                 </a:solidFill>
@@ -6627,7 +6761,7 @@
               <a:buNone/>
             </a:pPr>
             <a:r>
-              <a:rPr sz="800" b="0">
+              <a:rPr sz="1400" b="0" dirty="0">
                 <a:solidFill>
                   <a:srgbClr val="2D2D2D"/>
                 </a:solidFill>
@@ -6643,7 +6777,7 @@
               <a:buNone/>
             </a:pPr>
             <a:r>
-              <a:rPr sz="800" b="0">
+              <a:rPr sz="1400" b="0" dirty="0">
                 <a:solidFill>
                   <a:srgbClr val="2D2D2D"/>
                 </a:solidFill>
@@ -6661,7 +6795,7 @@
         </p:nvSpPr>
         <p:spPr>
           <a:xfrm>
-            <a:off x="2962656" y="4937760"/>
+            <a:off x="2962656" y="5376672"/>
             <a:ext cx="365760" cy="274320"/>
           </a:xfrm>
           <a:prstGeom prst="rect">
@@ -6670,7 +6804,7 @@
           <a:noFill/>
         </p:spPr>
         <p:txBody>
-          <a:bodyPr wrap="none" lIns="0" rIns="0" tIns="0" bIns="0">
+          <a:bodyPr wrap="none" lIns="0" tIns="0" rIns="0" bIns="0">
             <a:spAutoFit/>
           </a:bodyPr>
           <a:lstStyle/>
@@ -6697,7 +6831,7 @@
         </p:nvSpPr>
         <p:spPr>
           <a:xfrm>
-            <a:off x="3493008" y="4343400"/>
+            <a:off x="3493008" y="4782312"/>
             <a:ext cx="2240280" cy="1508760"/>
           </a:xfrm>
           <a:prstGeom prst="roundRect">
@@ -6727,7 +6861,7 @@
           </a:fontRef>
         </p:style>
         <p:txBody>
-          <a:bodyPr rtlCol="0" anchor="ctr" wrap="square" lIns="73152" rIns="73152" tIns="54864" bIns="54864"/>
+          <a:bodyPr wrap="square" lIns="73152" tIns="54864" rIns="73152" bIns="54864" rtlCol="0" anchor="ctr"/>
           <a:lstStyle/>
           <a:p>
             <a:pPr algn="ctr">
@@ -6737,7 +6871,7 @@
               <a:buNone/>
             </a:pPr>
             <a:r>
-              <a:rPr sz="950" b="1">
+              <a:rPr sz="1400" b="1" dirty="0">
                 <a:solidFill>
                   <a:srgbClr val="003C82"/>
                 </a:solidFill>
@@ -6753,7 +6887,7 @@
               <a:buNone/>
             </a:pPr>
             <a:r>
-              <a:rPr sz="800" b="0">
+              <a:rPr sz="1400" b="0" dirty="0">
                 <a:solidFill>
                   <a:srgbClr val="2D2D2D"/>
                 </a:solidFill>
@@ -6769,12 +6903,20 @@
               <a:buNone/>
             </a:pPr>
             <a:r>
-              <a:rPr sz="800" b="0">
-                <a:solidFill>
-                  <a:srgbClr val="2D2D2D"/>
-                </a:solidFill>
-              </a:rPr>
-              <a:t>eCourts live dockets,</a:t>
+              <a:rPr sz="1400" b="0" dirty="0" err="1">
+                <a:solidFill>
+                  <a:srgbClr val="2D2D2D"/>
+                </a:solidFill>
+              </a:rPr>
+              <a:t>eCourts</a:t>
+            </a:r>
+            <a:r>
+              <a:rPr sz="1400" b="0" dirty="0">
+                <a:solidFill>
+                  <a:srgbClr val="2D2D2D"/>
+                </a:solidFill>
+              </a:rPr>
+              <a:t> live dockets,</a:t>
             </a:r>
           </a:p>
           <a:p>
@@ -6785,7 +6927,7 @@
               <a:buNone/>
             </a:pPr>
             <a:r>
-              <a:rPr sz="800" b="0">
+              <a:rPr sz="1400" b="0" dirty="0">
                 <a:solidFill>
                   <a:srgbClr val="2D2D2D"/>
                 </a:solidFill>
@@ -6803,7 +6945,7 @@
         </p:nvSpPr>
         <p:spPr>
           <a:xfrm>
-            <a:off x="5843016" y="4937760"/>
+            <a:off x="5843016" y="5376672"/>
             <a:ext cx="365760" cy="274320"/>
           </a:xfrm>
           <a:prstGeom prst="rect">
@@ -6812,7 +6954,7 @@
           <a:noFill/>
         </p:spPr>
         <p:txBody>
-          <a:bodyPr wrap="none" lIns="0" rIns="0" tIns="0" bIns="0">
+          <a:bodyPr wrap="none" lIns="0" tIns="0" rIns="0" bIns="0">
             <a:spAutoFit/>
           </a:bodyPr>
           <a:lstStyle/>
@@ -6839,7 +6981,7 @@
         </p:nvSpPr>
         <p:spPr>
           <a:xfrm>
-            <a:off x="6373368" y="4343400"/>
+            <a:off x="6373368" y="4782312"/>
             <a:ext cx="2240280" cy="1508760"/>
           </a:xfrm>
           <a:prstGeom prst="roundRect">
@@ -6869,7 +7011,7 @@
           </a:fontRef>
         </p:style>
         <p:txBody>
-          <a:bodyPr rtlCol="0" anchor="ctr" wrap="square" lIns="73152" rIns="73152" tIns="54864" bIns="54864"/>
+          <a:bodyPr wrap="square" lIns="73152" tIns="54864" rIns="73152" bIns="54864" rtlCol="0" anchor="ctr"/>
           <a:lstStyle/>
           <a:p>
             <a:pPr algn="ctr">
@@ -6879,7 +7021,7 @@
               <a:buNone/>
             </a:pPr>
             <a:r>
-              <a:rPr sz="950" b="1">
+              <a:rPr sz="1400" b="1" dirty="0">
                 <a:solidFill>
                   <a:srgbClr val="D75F00"/>
                 </a:solidFill>
@@ -6895,7 +7037,7 @@
               <a:buNone/>
             </a:pPr>
             <a:r>
-              <a:rPr sz="800" b="0">
+              <a:rPr sz="1400" b="0" dirty="0">
                 <a:solidFill>
                   <a:srgbClr val="2D2D2D"/>
                 </a:solidFill>
@@ -6911,7 +7053,7 @@
               <a:buNone/>
             </a:pPr>
             <a:r>
-              <a:rPr sz="800" b="0">
+              <a:rPr sz="1400" b="0" dirty="0">
                 <a:solidFill>
                   <a:srgbClr val="2D2D2D"/>
                 </a:solidFill>
@@ -6927,7 +7069,7 @@
               <a:buNone/>
             </a:pPr>
             <a:r>
-              <a:rPr sz="800" b="0">
+              <a:rPr sz="1400" b="0" dirty="0">
                 <a:solidFill>
                   <a:srgbClr val="2D2D2D"/>
                 </a:solidFill>
@@ -6945,7 +7087,7 @@
         </p:nvSpPr>
         <p:spPr>
           <a:xfrm>
-            <a:off x="8723376" y="4937760"/>
+            <a:off x="8723376" y="5376672"/>
             <a:ext cx="365760" cy="274320"/>
           </a:xfrm>
           <a:prstGeom prst="rect">
@@ -6954,7 +7096,7 @@
           <a:noFill/>
         </p:spPr>
         <p:txBody>
-          <a:bodyPr wrap="none" lIns="0" rIns="0" tIns="0" bIns="0">
+          <a:bodyPr wrap="none" lIns="0" tIns="0" rIns="0" bIns="0">
             <a:spAutoFit/>
           </a:bodyPr>
           <a:lstStyle/>
@@ -6981,7 +7123,7 @@
         </p:nvSpPr>
         <p:spPr>
           <a:xfrm>
-            <a:off x="9253728" y="4343400"/>
+            <a:off x="9253728" y="4782312"/>
             <a:ext cx="2240280" cy="1508760"/>
           </a:xfrm>
           <a:prstGeom prst="roundRect">
@@ -7011,7 +7153,7 @@
           </a:fontRef>
         </p:style>
         <p:txBody>
-          <a:bodyPr rtlCol="0" anchor="ctr" wrap="square" lIns="73152" rIns="73152" tIns="54864" bIns="54864"/>
+          <a:bodyPr wrap="square" lIns="73152" tIns="54864" rIns="73152" bIns="54864" rtlCol="0" anchor="ctr"/>
           <a:lstStyle/>
           <a:p>
             <a:pPr algn="ctr">
@@ -7021,7 +7163,7 @@
               <a:buNone/>
             </a:pPr>
             <a:r>
-              <a:rPr sz="950" b="1">
+              <a:rPr sz="1400" b="1" dirty="0">
                 <a:solidFill>
                   <a:srgbClr val="008C4B"/>
                 </a:solidFill>
@@ -7037,7 +7179,7 @@
               <a:buNone/>
             </a:pPr>
             <a:r>
-              <a:rPr sz="800" b="0">
+              <a:rPr sz="1400" b="0" dirty="0">
                 <a:solidFill>
                   <a:srgbClr val="2D2D2D"/>
                 </a:solidFill>
@@ -7053,7 +7195,7 @@
               <a:buNone/>
             </a:pPr>
             <a:r>
-              <a:rPr sz="800" b="0">
+              <a:rPr sz="1400" b="0" dirty="0">
                 <a:solidFill>
                   <a:srgbClr val="2D2D2D"/>
                 </a:solidFill>
@@ -7069,7 +7211,7 @@
               <a:buNone/>
             </a:pPr>
             <a:r>
-              <a:rPr sz="800" b="0">
+              <a:rPr sz="1400" b="0" dirty="0">
                 <a:solidFill>
                   <a:srgbClr val="2D2D2D"/>
                 </a:solidFill>
@@ -7106,70 +7248,6 @@
       </p:grpSpPr>
       <p:sp>
         <p:nvSpPr>
-          <p:cNvPr id="10" name="Rectangle 9">
-            <a:extLst>
-              <a:ext uri="{FF2B5EF4-FFF2-40B4-BE49-F238E27FC236}">
-                <a16:creationId xmlns:a16="http://schemas.microsoft.com/office/drawing/2014/main" id="{AD4F69D3-EEB0-4C4C-9434-B9960FB5854C}"/>
-              </a:ext>
-            </a:extLst>
-          </p:cNvPr>
-          <p:cNvSpPr>
-            <a:spLocks noChangeArrowheads="1"/>
-          </p:cNvSpPr>
-          <p:nvPr/>
-        </p:nvSpPr>
-        <p:spPr bwMode="auto">
-          <a:xfrm>
-            <a:off x="0" y="6354762"/>
-            <a:ext cx="12191999" cy="503238"/>
-          </a:xfrm>
-          <a:prstGeom prst="rect">
-            <a:avLst/>
-          </a:prstGeom>
-          <a:solidFill>
-            <a:srgbClr val="0070C0"/>
-          </a:solidFill>
-          <a:ln w="9525">
-            <a:noFill/>
-            <a:miter lim="800000"/>
-            <a:headEnd/>
-            <a:tailEnd/>
-          </a:ln>
-          <a:effectLst>
-            <a:outerShdw dist="23000" dir="5400000" rotWithShape="0">
-              <a:srgbClr val="808080">
-                <a:alpha val="34999"/>
-              </a:srgbClr>
-            </a:outerShdw>
-          </a:effectLst>
-        </p:spPr>
-        <p:txBody>
-          <a:bodyPr anchor="ctr"/>
-          <a:lstStyle/>
-          <a:p>
-            <a:pPr algn="ctr" fontAlgn="auto">
-              <a:spcBef>
-                <a:spcPts val="0"/>
-              </a:spcBef>
-              <a:spcAft>
-                <a:spcPts val="0"/>
-              </a:spcAft>
-              <a:defRPr/>
-            </a:pPr>
-            <a:endParaRPr lang="en-US" dirty="0">
-              <a:solidFill>
-                <a:schemeClr val="accent2">
-                  <a:lumMod val="75000"/>
-                </a:schemeClr>
-              </a:solidFill>
-              <a:latin typeface="+mn-lt"/>
-              <a:ea typeface="+mn-ea"/>
-            </a:endParaRPr>
-          </a:p>
-        </p:txBody>
-      </p:sp>
-      <p:sp>
-        <p:nvSpPr>
           <p:cNvPr id="17409" name="Title 1"/>
           <p:cNvSpPr>
             <a:spLocks noGrp="1"/>
@@ -7206,7 +7284,7 @@
         <p:spPr bwMode="auto">
           <a:xfrm>
             <a:off x="612648" y="1207008"/>
-            <a:ext cx="10972800" cy="3017520"/>
+            <a:ext cx="10972800" cy="3077253"/>
           </a:xfrm>
           <a:prstGeom prst="rect">
             <a:avLst/>
@@ -7220,7 +7298,7 @@
           </a:ln>
         </p:spPr>
         <p:txBody>
-          <a:bodyPr wrap="square" lIns="45720" rIns="45720" tIns="36576" bIns="36576">
+          <a:bodyPr wrap="square" lIns="45720" tIns="36576" rIns="45720" bIns="36576">
             <a:spAutoFit/>
           </a:bodyPr>
           <a:lstStyle/>
@@ -7235,7 +7313,7 @@
               <a:buNone/>
             </a:pPr>
             <a:r>
-              <a:rPr sz="1050" b="1">
+              <a:rPr sz="2000" b="1" dirty="0">
                 <a:solidFill>
                   <a:srgbClr val="003C82"/>
                 </a:solidFill>
@@ -7254,7 +7332,7 @@
               <a:buNone/>
             </a:pPr>
             <a:r>
-              <a:rPr sz="900" b="0">
+              <a:rPr sz="1700" b="0" dirty="0">
                 <a:solidFill>
                   <a:srgbClr val="2D2D2D"/>
                 </a:solidFill>
@@ -7273,12 +7351,28 @@
               <a:buNone/>
             </a:pPr>
             <a:r>
-              <a:rPr sz="900" b="0">
-                <a:solidFill>
-                  <a:srgbClr val="2D2D2D"/>
-                </a:solidFill>
-              </a:rPr>
-              <a:t>  • Secure Database: PostgreSQL via Supabase with Row-Level Security (RLS), atomic RPCs, and zero client-side secrets.</a:t>
+              <a:rPr sz="1700" b="0" dirty="0">
+                <a:solidFill>
+                  <a:srgbClr val="2D2D2D"/>
+                </a:solidFill>
+              </a:rPr>
+              <a:t>  • Secure Database: PostgreSQL via </a:t>
+            </a:r>
+            <a:r>
+              <a:rPr sz="1700" b="0" dirty="0" err="1">
+                <a:solidFill>
+                  <a:srgbClr val="2D2D2D"/>
+                </a:solidFill>
+              </a:rPr>
+              <a:t>Supabase</a:t>
+            </a:r>
+            <a:r>
+              <a:rPr sz="1700" b="0" dirty="0">
+                <a:solidFill>
+                  <a:srgbClr val="2D2D2D"/>
+                </a:solidFill>
+              </a:rPr>
+              <a:t> with Row-Level Security (RLS), atomic RPCs, and zero client-side secrets.</a:t>
             </a:r>
           </a:p>
           <a:p>
@@ -7292,12 +7386,44 @@
               <a:buNone/>
             </a:pPr>
             <a:r>
-              <a:rPr sz="900" b="0">
-                <a:solidFill>
-                  <a:srgbClr val="2D2D2D"/>
-                </a:solidFill>
-              </a:rPr>
-              <a:t>  • Automated Ingestion: Python pipelines (BeautifulSoup, pandas, requests) scraping ECI, eCourts &amp; Sansad.in.</a:t>
+              <a:rPr sz="1700" b="0" dirty="0">
+                <a:solidFill>
+                  <a:srgbClr val="2D2D2D"/>
+                </a:solidFill>
+              </a:rPr>
+              <a:t>  • Automated Ingestion: Python pipelines (</a:t>
+            </a:r>
+            <a:r>
+              <a:rPr sz="1700" b="0" dirty="0" err="1">
+                <a:solidFill>
+                  <a:srgbClr val="2D2D2D"/>
+                </a:solidFill>
+              </a:rPr>
+              <a:t>BeautifulSoup</a:t>
+            </a:r>
+            <a:r>
+              <a:rPr sz="1700" b="0" dirty="0">
+                <a:solidFill>
+                  <a:srgbClr val="2D2D2D"/>
+                </a:solidFill>
+              </a:rPr>
+              <a:t>, pandas, requests) scraping ECI, </a:t>
+            </a:r>
+            <a:r>
+              <a:rPr sz="1700" b="0" dirty="0" err="1">
+                <a:solidFill>
+                  <a:srgbClr val="2D2D2D"/>
+                </a:solidFill>
+              </a:rPr>
+              <a:t>eCourts</a:t>
+            </a:r>
+            <a:r>
+              <a:rPr sz="1700" b="0" dirty="0">
+                <a:solidFill>
+                  <a:srgbClr val="2D2D2D"/>
+                </a:solidFill>
+              </a:rPr>
+              <a:t> &amp; Sansad.in.</a:t>
             </a:r>
           </a:p>
           <a:p>
@@ -7311,7 +7437,7 @@
               <a:buNone/>
             </a:pPr>
             <a:r>
-              <a:rPr sz="900" b="0">
+              <a:rPr sz="1700" b="0" dirty="0">
                 <a:solidFill>
                   <a:srgbClr val="2D2D2D"/>
                 </a:solidFill>
@@ -7330,12 +7456,28 @@
               <a:buNone/>
             </a:pPr>
             <a:r>
-              <a:rPr sz="900" b="0">
-                <a:solidFill>
-                  <a:srgbClr val="2D2D2D"/>
-                </a:solidFill>
-              </a:rPr>
-              <a:t>  • Security &amp; SRE: SSRF proxy validation, sliding-window rate limiting, Sentry telemetry, and 0-emoji Lucide icons.</a:t>
+              <a:rPr sz="1700" b="0" dirty="0">
+                <a:solidFill>
+                  <a:srgbClr val="2D2D2D"/>
+                </a:solidFill>
+              </a:rPr>
+              <a:t>  • Security &amp; SRE: SSRF proxy validation, sliding-window rate limiting, Sentry telemetry, and 0-emoji </a:t>
+            </a:r>
+            <a:r>
+              <a:rPr sz="1700" b="0" dirty="0" err="1">
+                <a:solidFill>
+                  <a:srgbClr val="2D2D2D"/>
+                </a:solidFill>
+              </a:rPr>
+              <a:t>Lucide</a:t>
+            </a:r>
+            <a:r>
+              <a:rPr sz="1700" b="0" dirty="0">
+                <a:solidFill>
+                  <a:srgbClr val="2D2D2D"/>
+                </a:solidFill>
+              </a:rPr>
+              <a:t> icons.</a:t>
             </a:r>
           </a:p>
           <a:p>
@@ -7349,7 +7491,7 @@
               <a:buNone/>
             </a:pPr>
             <a:r>
-              <a:rPr sz="1050" b="1">
+              <a:rPr sz="2000" b="1" dirty="0">
                 <a:solidFill>
                   <a:srgbClr val="003C82"/>
                 </a:solidFill>
@@ -7368,7 +7510,7 @@
               <a:buNone/>
             </a:pPr>
             <a:r>
-              <a:rPr sz="900" b="0">
+              <a:rPr sz="1700" b="0" dirty="0">
                 <a:solidFill>
                   <a:srgbClr val="2D2D2D"/>
                 </a:solidFill>
@@ -7387,7 +7529,7 @@
               <a:buNone/>
             </a:pPr>
             <a:r>
-              <a:rPr sz="900" b="0">
+              <a:rPr sz="1700" b="0" dirty="0">
                 <a:solidFill>
                   <a:srgbClr val="2D2D2D"/>
                 </a:solidFill>
@@ -7406,7 +7548,7 @@
               <a:buNone/>
             </a:pPr>
             <a:r>
-              <a:rPr sz="900" b="0">
+              <a:rPr sz="1700" b="0" dirty="0">
                 <a:solidFill>
                   <a:srgbClr val="2D2D2D"/>
                 </a:solidFill>
@@ -7450,52 +7592,13 @@
       </p:sp>
       <p:sp>
         <p:nvSpPr>
-          <p:cNvPr id="7" name="Footer Placeholder 6"/>
-          <p:cNvSpPr>
-            <a:spLocks noGrp="1"/>
-          </p:cNvSpPr>
-          <p:nvPr>
-            <p:ph type="ftr" sz="quarter" idx="11"/>
-          </p:nvPr>
-        </p:nvSpPr>
-        <p:spPr>
-          <a:xfrm>
-            <a:off x="4648200" y="6356353"/>
-            <a:ext cx="3204000" cy="365125"/>
-          </a:xfrm>
-        </p:spPr>
-        <p:txBody>
-          <a:bodyPr/>
-          <a:lstStyle/>
-          <a:p>
-            <a:pPr>
-              <a:defRPr/>
-            </a:pPr>
-            <a:r>
-              <a:rPr lang="en-US">
-                <a:solidFill>
-                  <a:schemeClr val="bg1"/>
-                </a:solidFill>
-              </a:rPr>
-              <a:t>@SIH Idea submission- Template</a:t>
-            </a:r>
-            <a:endParaRPr lang="en-US" dirty="0">
-              <a:solidFill>
-                <a:schemeClr val="bg1"/>
-              </a:solidFill>
-            </a:endParaRPr>
-          </a:p>
-        </p:txBody>
-      </p:sp>
-      <p:sp>
-        <p:nvSpPr>
           <p:cNvPr id="11" name="Oval 10" descr="Your startup LOGO">
             <a:extLst>
               <a:ext uri="{FF2B5EF4-FFF2-40B4-BE49-F238E27FC236}">
                 <a16:creationId xmlns:a16="http://schemas.microsoft.com/office/drawing/2014/main" id="{5DBCE864-823D-4A13-9607-5DA1F0ED5FB8}"/>
               </a:ext>
               <a:ext uri="{C183D7F6-B498-43B3-948B-1728B52AA6E4}">
-                <adec:decorative xmlns:adec="http://schemas.microsoft.com/office/drawing/2017/decorative" xmlns="" val="0"/>
+                <adec:decorative xmlns:adec="http://schemas.microsoft.com/office/drawing/2017/decorative" val="0"/>
               </a:ext>
             </a:extLst>
           </p:cNvPr>
@@ -7590,7 +7693,7 @@
         </p:nvSpPr>
         <p:spPr>
           <a:xfrm>
-            <a:off x="612648" y="4343400"/>
+            <a:off x="457199" y="4983480"/>
             <a:ext cx="1783080" cy="1508760"/>
           </a:xfrm>
           <a:prstGeom prst="roundRect">
@@ -7620,7 +7723,7 @@
           </a:fontRef>
         </p:style>
         <p:txBody>
-          <a:bodyPr rtlCol="0" anchor="ctr" wrap="square" lIns="73152" rIns="73152" tIns="54864" bIns="54864"/>
+          <a:bodyPr wrap="square" lIns="73152" tIns="54864" rIns="73152" bIns="54864" rtlCol="0" anchor="ctr"/>
           <a:lstStyle/>
           <a:p>
             <a:pPr algn="ctr">
@@ -7630,7 +7733,7 @@
               <a:buNone/>
             </a:pPr>
             <a:r>
-              <a:rPr sz="950" b="1">
+              <a:rPr sz="1400" b="1" dirty="0">
                 <a:solidFill>
                   <a:srgbClr val="0050A0"/>
                 </a:solidFill>
@@ -7646,7 +7749,7 @@
               <a:buNone/>
             </a:pPr>
             <a:r>
-              <a:rPr sz="800" b="0">
+              <a:rPr sz="1400" b="0" dirty="0">
                 <a:solidFill>
                   <a:srgbClr val="2D2D2D"/>
                 </a:solidFill>
@@ -7662,7 +7765,7 @@
               <a:buNone/>
             </a:pPr>
             <a:r>
-              <a:rPr sz="800" b="0">
+              <a:rPr sz="1400" b="0" dirty="0">
                 <a:solidFill>
                   <a:srgbClr val="2D2D2D"/>
                 </a:solidFill>
@@ -7680,7 +7783,7 @@
         </p:nvSpPr>
         <p:spPr>
           <a:xfrm>
-            <a:off x="2505456" y="4343400"/>
+            <a:off x="2350007" y="4983480"/>
             <a:ext cx="1783080" cy="1508760"/>
           </a:xfrm>
           <a:prstGeom prst="roundRect">
@@ -7710,7 +7813,7 @@
           </a:fontRef>
         </p:style>
         <p:txBody>
-          <a:bodyPr rtlCol="0" anchor="ctr" wrap="square" lIns="73152" rIns="73152" tIns="54864" bIns="54864"/>
+          <a:bodyPr wrap="square" lIns="73152" tIns="54864" rIns="73152" bIns="54864" rtlCol="0" anchor="ctr"/>
           <a:lstStyle/>
           <a:p>
             <a:pPr algn="ctr">
@@ -7720,12 +7823,20 @@
               <a:buNone/>
             </a:pPr>
             <a:r>
-              <a:rPr sz="950" b="1">
+              <a:rPr sz="1400" b="1" dirty="0" err="1">
                 <a:solidFill>
                   <a:srgbClr val="00785A"/>
                 </a:solidFill>
               </a:rPr>
-              <a:t>eCourts NJDG</a:t>
+              <a:t>eCourts</a:t>
+            </a:r>
+            <a:r>
+              <a:rPr sz="1400" b="1" dirty="0">
+                <a:solidFill>
+                  <a:srgbClr val="00785A"/>
+                </a:solidFill>
+              </a:rPr>
+              <a:t> NJDG</a:t>
             </a:r>
           </a:p>
           <a:p>
@@ -7736,7 +7847,7 @@
               <a:buNone/>
             </a:pPr>
             <a:r>
-              <a:rPr sz="800" b="0">
+              <a:rPr sz="1400" b="0" dirty="0">
                 <a:solidFill>
                   <a:srgbClr val="2D2D2D"/>
                 </a:solidFill>
@@ -7752,7 +7863,7 @@
               <a:buNone/>
             </a:pPr>
             <a:r>
-              <a:rPr sz="800" b="0">
+              <a:rPr sz="1400" b="0" dirty="0">
                 <a:solidFill>
                   <a:srgbClr val="2D2D2D"/>
                 </a:solidFill>
@@ -7770,7 +7881,7 @@
         </p:nvSpPr>
         <p:spPr>
           <a:xfrm>
-            <a:off x="4398264" y="4343400"/>
+            <a:off x="4242815" y="4983480"/>
             <a:ext cx="1783080" cy="1508760"/>
           </a:xfrm>
           <a:prstGeom prst="roundRect">
@@ -7800,7 +7911,7 @@
           </a:fontRef>
         </p:style>
         <p:txBody>
-          <a:bodyPr rtlCol="0" anchor="ctr" wrap="square" lIns="73152" rIns="73152" tIns="54864" bIns="54864"/>
+          <a:bodyPr wrap="square" lIns="73152" tIns="54864" rIns="73152" bIns="54864" rtlCol="0" anchor="ctr"/>
           <a:lstStyle/>
           <a:p>
             <a:pPr algn="ctr">
@@ -7810,7 +7921,7 @@
               <a:buNone/>
             </a:pPr>
             <a:r>
-              <a:rPr sz="950" b="1">
+              <a:rPr sz="1400" b="1" dirty="0">
                 <a:solidFill>
                   <a:srgbClr val="B45A00"/>
                 </a:solidFill>
@@ -7826,7 +7937,7 @@
               <a:buNone/>
             </a:pPr>
             <a:r>
-              <a:rPr sz="800" b="0">
+              <a:rPr sz="1400" b="0" dirty="0">
                 <a:solidFill>
                   <a:srgbClr val="2D2D2D"/>
                 </a:solidFill>
@@ -7842,7 +7953,7 @@
               <a:buNone/>
             </a:pPr>
             <a:r>
-              <a:rPr sz="800" b="0">
+              <a:rPr sz="1400" b="0" dirty="0">
                 <a:solidFill>
                   <a:srgbClr val="2D2D2D"/>
                 </a:solidFill>
@@ -7860,7 +7971,7 @@
         </p:nvSpPr>
         <p:spPr>
           <a:xfrm>
-            <a:off x="6291071" y="4343400"/>
+            <a:off x="6135622" y="4983480"/>
             <a:ext cx="1783080" cy="1508760"/>
           </a:xfrm>
           <a:prstGeom prst="roundRect">
@@ -7890,7 +8001,7 @@
           </a:fontRef>
         </p:style>
         <p:txBody>
-          <a:bodyPr rtlCol="0" anchor="ctr" wrap="square" lIns="73152" rIns="73152" tIns="54864" bIns="54864"/>
+          <a:bodyPr wrap="square" lIns="73152" tIns="54864" rIns="73152" bIns="54864" rtlCol="0" anchor="ctr"/>
           <a:lstStyle/>
           <a:p>
             <a:pPr algn="ctr">
@@ -7900,7 +8011,7 @@
               <a:buNone/>
             </a:pPr>
             <a:r>
-              <a:rPr sz="950" b="1">
+              <a:rPr sz="1400" b="1" dirty="0">
                 <a:solidFill>
                   <a:srgbClr val="B42828"/>
                 </a:solidFill>
@@ -7916,7 +8027,7 @@
               <a:buNone/>
             </a:pPr>
             <a:r>
-              <a:rPr sz="800" b="0">
+              <a:rPr sz="1400" b="0" dirty="0">
                 <a:solidFill>
                   <a:srgbClr val="2D2D2D"/>
                 </a:solidFill>
@@ -7932,7 +8043,7 @@
               <a:buNone/>
             </a:pPr>
             <a:r>
-              <a:rPr sz="800" b="0">
+              <a:rPr sz="1400" b="0" dirty="0">
                 <a:solidFill>
                   <a:srgbClr val="2D2D2D"/>
                 </a:solidFill>
@@ -7950,7 +8061,7 @@
         </p:nvSpPr>
         <p:spPr>
           <a:xfrm>
-            <a:off x="8229600" y="4937760"/>
+            <a:off x="8074151" y="5577840"/>
             <a:ext cx="365760" cy="274320"/>
           </a:xfrm>
           <a:prstGeom prst="rect">
@@ -7959,7 +8070,7 @@
           <a:noFill/>
         </p:spPr>
         <p:txBody>
-          <a:bodyPr wrap="none" lIns="0" rIns="0" tIns="0" bIns="0">
+          <a:bodyPr wrap="none" lIns="0" tIns="0" rIns="0" bIns="0">
             <a:spAutoFit/>
           </a:bodyPr>
           <a:lstStyle/>
@@ -7986,7 +8097,7 @@
         </p:nvSpPr>
         <p:spPr>
           <a:xfrm>
-            <a:off x="8641080" y="4343400"/>
+            <a:off x="8485631" y="4983480"/>
             <a:ext cx="2926080" cy="1508760"/>
           </a:xfrm>
           <a:prstGeom prst="roundRect">
@@ -8016,7 +8127,7 @@
           </a:fontRef>
         </p:style>
         <p:txBody>
-          <a:bodyPr rtlCol="0" anchor="ctr" wrap="square" lIns="73152" rIns="73152" tIns="54864" bIns="54864"/>
+          <a:bodyPr wrap="square" lIns="73152" tIns="54864" rIns="73152" bIns="54864" rtlCol="0" anchor="ctr"/>
           <a:lstStyle/>
           <a:p>
             <a:pPr algn="ctr">
@@ -8026,7 +8137,7 @@
               <a:buNone/>
             </a:pPr>
             <a:r>
-              <a:rPr sz="1000" b="1">
+              <a:rPr sz="1400" b="1" dirty="0">
                 <a:solidFill>
                   <a:srgbClr val="008C4B"/>
                 </a:solidFill>
@@ -8042,7 +8153,7 @@
               <a:buNone/>
             </a:pPr>
             <a:r>
-              <a:rPr sz="800" b="0">
+              <a:rPr sz="1400" b="0" dirty="0">
                 <a:solidFill>
                   <a:srgbClr val="2D2D2D"/>
                 </a:solidFill>
@@ -8058,7 +8169,7 @@
               <a:buNone/>
             </a:pPr>
             <a:r>
-              <a:rPr sz="800" b="0">
+              <a:rPr sz="1400" b="0" dirty="0">
                 <a:solidFill>
                   <a:srgbClr val="2D2D2D"/>
                 </a:solidFill>
@@ -8074,7 +8185,7 @@
               <a:buNone/>
             </a:pPr>
             <a:r>
-              <a:rPr sz="800" b="0">
+              <a:rPr sz="1400" b="0" dirty="0">
                 <a:solidFill>
                   <a:srgbClr val="2D2D2D"/>
                 </a:solidFill>
@@ -8090,7 +8201,7 @@
               <a:buNone/>
             </a:pPr>
             <a:r>
-              <a:rPr sz="800" b="0">
+              <a:rPr sz="1400" b="0" dirty="0">
                 <a:solidFill>
                   <a:srgbClr val="2D2D2D"/>
                 </a:solidFill>
@@ -8127,85 +8238,6 @@
       </p:grpSpPr>
       <p:sp>
         <p:nvSpPr>
-          <p:cNvPr id="10" name="Rectangle 9">
-            <a:extLst>
-              <a:ext uri="{FF2B5EF4-FFF2-40B4-BE49-F238E27FC236}">
-                <a16:creationId xmlns:a16="http://schemas.microsoft.com/office/drawing/2014/main" id="{AD4F69D3-EEB0-4C4C-9434-B9960FB5854C}"/>
-              </a:ext>
-            </a:extLst>
-          </p:cNvPr>
-          <p:cNvSpPr>
-            <a:spLocks noChangeArrowheads="1"/>
-          </p:cNvSpPr>
-          <p:nvPr/>
-        </p:nvSpPr>
-        <p:spPr bwMode="auto">
-          <a:xfrm>
-            <a:off x="0" y="6354762"/>
-            <a:ext cx="12191999" cy="503238"/>
-          </a:xfrm>
-          <a:prstGeom prst="rect">
-            <a:avLst/>
-          </a:prstGeom>
-          <a:solidFill>
-            <a:srgbClr val="0070C0"/>
-          </a:solidFill>
-          <a:ln w="9525">
-            <a:noFill/>
-            <a:miter lim="800000"/>
-            <a:headEnd/>
-            <a:tailEnd/>
-          </a:ln>
-          <a:effectLst>
-            <a:outerShdw dist="23000" dir="5400000" rotWithShape="0">
-              <a:srgbClr val="808080">
-                <a:alpha val="34999"/>
-              </a:srgbClr>
-            </a:outerShdw>
-          </a:effectLst>
-        </p:spPr>
-        <p:txBody>
-          <a:bodyPr anchor="ctr"/>
-          <a:lstStyle/>
-          <a:p>
-            <a:pPr marL="0" marR="0" lvl="0" indent="0" algn="ctr" defTabSz="457200" rtl="0" eaLnBrk="1" fontAlgn="auto" latinLnBrk="0" hangingPunct="1">
-              <a:lnSpc>
-                <a:spcPct val="100000"/>
-              </a:lnSpc>
-              <a:spcBef>
-                <a:spcPts val="0"/>
-              </a:spcBef>
-              <a:spcAft>
-                <a:spcPts val="0"/>
-              </a:spcAft>
-              <a:buClrTx/>
-              <a:buSzTx/>
-              <a:buFontTx/>
-              <a:buNone/>
-              <a:tabLst/>
-              <a:defRPr/>
-            </a:pPr>
-            <a:endParaRPr kumimoji="0" lang="en-US" sz="1800" b="0" i="0" u="none" strike="noStrike" kern="1200" cap="none" spc="0" normalizeH="0" baseline="0" noProof="0" dirty="0">
-              <a:ln>
-                <a:noFill/>
-              </a:ln>
-              <a:solidFill>
-                <a:srgbClr val="C0504D">
-                  <a:lumMod val="75000"/>
-                </a:srgbClr>
-              </a:solidFill>
-              <a:effectLst/>
-              <a:uLnTx/>
-              <a:uFillTx/>
-              <a:latin typeface="Calibri"/>
-              <a:ea typeface="ＭＳ Ｐゴシック" pitchFamily="1" charset="-128"/>
-              <a:cs typeface="+mn-cs"/>
-            </a:endParaRPr>
-          </a:p>
-        </p:txBody>
-      </p:sp>
-      <p:sp>
-        <p:nvSpPr>
           <p:cNvPr id="17409" name="Title 1"/>
           <p:cNvSpPr>
             <a:spLocks noGrp="1"/>
@@ -8241,8 +8273,8 @@
         </p:nvSpPr>
         <p:spPr bwMode="auto">
           <a:xfrm>
-            <a:off x="612648" y="1207008"/>
-            <a:ext cx="10972800" cy="3017520"/>
+            <a:off x="521207" y="1144500"/>
+            <a:ext cx="10972800" cy="3051605"/>
           </a:xfrm>
           <a:prstGeom prst="rect">
             <a:avLst/>
@@ -8256,7 +8288,7 @@
           </a:ln>
         </p:spPr>
         <p:txBody>
-          <a:bodyPr wrap="square" lIns="45720" rIns="45720" tIns="36576" bIns="36576">
+          <a:bodyPr wrap="square" lIns="45720" tIns="36576" rIns="45720" bIns="36576">
             <a:spAutoFit/>
           </a:bodyPr>
           <a:lstStyle/>
@@ -8275,17 +8307,16 @@
               <a:buSzTx/>
               <a:tabLst/>
               <a:defRPr/>
-              <a:buNone/>
-            </a:pPr>
-            <a:r>
-              <a:rPr sz="1050" b="1">
+            </a:pPr>
+            <a:r>
+              <a:rPr sz="2000" b="1" dirty="0">
                 <a:solidFill>
                   <a:srgbClr val="003C82"/>
                 </a:solidFill>
               </a:rPr>
               <a:t>IS VERDICT FEASIBLE? YES — PRODUCTION SYSTEM IS ALREADY LIVE &amp; TESTED:</a:t>
             </a:r>
-            <a:endParaRPr kumimoji="0" lang="en-US" sz="2800" b="0" i="0" u="none" strike="noStrike" kern="1200" cap="none" spc="0" normalizeH="0" baseline="0" noProof="0" dirty="0">
+            <a:endParaRPr kumimoji="0" lang="en-US" sz="2000" b="0" i="0" u="none" strike="noStrike" kern="1200" cap="none" spc="0" normalizeH="0" baseline="0" noProof="0" dirty="0">
               <a:ln>
                 <a:noFill/>
               </a:ln>
@@ -8311,12 +8342,36 @@
               <a:buNone/>
             </a:pPr>
             <a:r>
-              <a:rPr sz="900" b="0">
-                <a:solidFill>
-                  <a:srgbClr val="2D2D2D"/>
-                </a:solidFill>
-              </a:rPr>
-              <a:t>  • Live Production Build: 593 static routes pre-rendered on Vercel at https://verdict.vercel.app with 0 build errors.</a:t>
+              <a:rPr sz="900" b="0" dirty="0">
+                <a:solidFill>
+                  <a:srgbClr val="2D2D2D"/>
+                </a:solidFill>
+              </a:rPr>
+              <a:t>  </a:t>
+            </a:r>
+            <a:r>
+              <a:rPr sz="1700" b="0" dirty="0">
+                <a:solidFill>
+                  <a:srgbClr val="2D2D2D"/>
+                </a:solidFill>
+              </a:rPr>
+              <a:t>• Live Production Build: 593 static routes pre-rendered on </a:t>
+            </a:r>
+            <a:r>
+              <a:rPr sz="1700" b="0" dirty="0" err="1">
+                <a:solidFill>
+                  <a:srgbClr val="2D2D2D"/>
+                </a:solidFill>
+              </a:rPr>
+              <a:t>Vercel</a:t>
+            </a:r>
+            <a:r>
+              <a:rPr sz="1700" b="0" dirty="0">
+                <a:solidFill>
+                  <a:srgbClr val="2D2D2D"/>
+                </a:solidFill>
+              </a:rPr>
+              <a:t> at https://verdict.vercel.app with 0 build errors.</a:t>
             </a:r>
           </a:p>
           <a:p>
@@ -8330,7 +8385,7 @@
               <a:buNone/>
             </a:pPr>
             <a:r>
-              <a:rPr sz="900" b="0">
+              <a:rPr sz="1700" b="0" dirty="0">
                 <a:solidFill>
                   <a:srgbClr val="2D2D2D"/>
                 </a:solidFill>
@@ -8349,7 +8404,7 @@
               <a:buNone/>
             </a:pPr>
             <a:r>
-              <a:rPr sz="900" b="0">
+              <a:rPr sz="1700" b="0" dirty="0">
                 <a:solidFill>
                   <a:srgbClr val="2D2D2D"/>
                 </a:solidFill>
@@ -8368,7 +8423,7 @@
               <a:buNone/>
             </a:pPr>
             <a:r>
-              <a:rPr sz="900" b="0">
+              <a:rPr sz="1700" b="0" dirty="0">
                 <a:solidFill>
                   <a:srgbClr val="2D2D2D"/>
                 </a:solidFill>
@@ -8387,7 +8442,7 @@
               <a:buNone/>
             </a:pPr>
             <a:r>
-              <a:rPr sz="1050" b="1">
+              <a:rPr sz="2000" b="1" dirty="0">
                 <a:solidFill>
                   <a:srgbClr val="003C82"/>
                 </a:solidFill>
@@ -8406,7 +8461,7 @@
               <a:buNone/>
             </a:pPr>
             <a:r>
-              <a:rPr sz="900" b="0">
+              <a:rPr sz="1700" b="0" dirty="0">
                 <a:solidFill>
                   <a:srgbClr val="2D2D2D"/>
                 </a:solidFill>
@@ -8425,7 +8480,7 @@
               <a:buNone/>
             </a:pPr>
             <a:r>
-              <a:rPr sz="900" b="0">
+              <a:rPr sz="1700" b="0" dirty="0">
                 <a:solidFill>
                   <a:srgbClr val="2D2D2D"/>
                 </a:solidFill>
@@ -8444,7 +8499,7 @@
               <a:buNone/>
             </a:pPr>
             <a:r>
-              <a:rPr sz="900" b="0">
+              <a:rPr sz="1700" b="0" dirty="0">
                 <a:solidFill>
                   <a:srgbClr val="2D2D2D"/>
                 </a:solidFill>
@@ -8616,7 +8671,7 @@
                 <a16:creationId xmlns:a16="http://schemas.microsoft.com/office/drawing/2014/main" id="{5DBCE864-823D-4A13-9607-5DA1F0ED5FB8}"/>
               </a:ext>
               <a:ext uri="{C183D7F6-B498-43B3-948B-1728B52AA6E4}">
-                <adec:decorative xmlns:adec="http://schemas.microsoft.com/office/drawing/2017/decorative" xmlns="" val="0"/>
+                <adec:decorative xmlns:adec="http://schemas.microsoft.com/office/drawing/2017/decorative" val="0"/>
               </a:ext>
             </a:extLst>
           </p:cNvPr>
@@ -8741,7 +8796,7 @@
           </a:fontRef>
         </p:style>
         <p:txBody>
-          <a:bodyPr rtlCol="0" anchor="ctr" wrap="square" lIns="73152" rIns="73152" tIns="54864" bIns="54864"/>
+          <a:bodyPr wrap="square" lIns="73152" tIns="54864" rIns="73152" bIns="54864" rtlCol="0" anchor="ctr"/>
           <a:lstStyle/>
           <a:p>
             <a:pPr algn="ctr">
@@ -8751,7 +8806,7 @@
               <a:buNone/>
             </a:pPr>
             <a:r>
-              <a:rPr sz="950" b="1">
+              <a:rPr sz="1400" b="1" dirty="0">
                 <a:solidFill>
                   <a:srgbClr val="008C4B"/>
                 </a:solidFill>
@@ -8767,7 +8822,7 @@
               <a:buNone/>
             </a:pPr>
             <a:r>
-              <a:rPr sz="800" b="0">
+              <a:rPr sz="1400" b="0" dirty="0">
                 <a:solidFill>
                   <a:srgbClr val="2D2D2D"/>
                 </a:solidFill>
@@ -8783,7 +8838,7 @@
               <a:buNone/>
             </a:pPr>
             <a:r>
-              <a:rPr sz="800" b="0">
+              <a:rPr sz="1400" b="0" dirty="0">
                 <a:solidFill>
                   <a:srgbClr val="2D2D2D"/>
                 </a:solidFill>
@@ -8799,7 +8854,7 @@
               <a:buNone/>
             </a:pPr>
             <a:r>
-              <a:rPr sz="800" b="0">
+              <a:rPr sz="1400" b="0" dirty="0">
                 <a:solidFill>
                   <a:srgbClr val="2D2D2D"/>
                 </a:solidFill>
@@ -8815,7 +8870,7 @@
               <a:buNone/>
             </a:pPr>
             <a:r>
-              <a:rPr sz="800" b="0">
+              <a:rPr sz="1400" b="0" dirty="0">
                 <a:solidFill>
                   <a:srgbClr val="2D2D2D"/>
                 </a:solidFill>
@@ -8842,7 +8897,7 @@
           <a:noFill/>
         </p:spPr>
         <p:txBody>
-          <a:bodyPr wrap="none" lIns="0" rIns="0" tIns="0" bIns="0">
+          <a:bodyPr wrap="none" lIns="0" tIns="0" rIns="0" bIns="0">
             <a:spAutoFit/>
           </a:bodyPr>
           <a:lstStyle/>
@@ -8899,7 +8954,7 @@
           </a:fontRef>
         </p:style>
         <p:txBody>
-          <a:bodyPr rtlCol="0" anchor="ctr" wrap="square" lIns="73152" rIns="73152" tIns="54864" bIns="54864"/>
+          <a:bodyPr wrap="square" lIns="73152" tIns="54864" rIns="73152" bIns="54864" rtlCol="0" anchor="ctr"/>
           <a:lstStyle/>
           <a:p>
             <a:pPr algn="ctr">
@@ -8909,7 +8964,7 @@
               <a:buNone/>
             </a:pPr>
             <a:r>
-              <a:rPr sz="950" b="1">
+              <a:rPr sz="1400" b="1" dirty="0">
                 <a:solidFill>
                   <a:srgbClr val="1E82BE"/>
                 </a:solidFill>
@@ -8925,7 +8980,7 @@
               <a:buNone/>
             </a:pPr>
             <a:r>
-              <a:rPr sz="800" b="0">
+              <a:rPr sz="1400" b="0" dirty="0">
                 <a:solidFill>
                   <a:srgbClr val="2D2D2D"/>
                 </a:solidFill>
@@ -8941,7 +8996,7 @@
               <a:buNone/>
             </a:pPr>
             <a:r>
-              <a:rPr sz="800" b="0">
+              <a:rPr sz="1400" b="0" dirty="0">
                 <a:solidFill>
                   <a:srgbClr val="2D2D2D"/>
                 </a:solidFill>
@@ -8957,7 +9012,7 @@
               <a:buNone/>
             </a:pPr>
             <a:r>
-              <a:rPr sz="800" b="0">
+              <a:rPr sz="1400" b="0" dirty="0">
                 <a:solidFill>
                   <a:srgbClr val="2D2D2D"/>
                 </a:solidFill>
@@ -8973,7 +9028,7 @@
               <a:buNone/>
             </a:pPr>
             <a:r>
-              <a:rPr sz="800" b="0">
+              <a:rPr sz="1400" b="0" dirty="0">
                 <a:solidFill>
                   <a:srgbClr val="2D2D2D"/>
                 </a:solidFill>
@@ -9000,7 +9055,7 @@
           <a:noFill/>
         </p:spPr>
         <p:txBody>
-          <a:bodyPr wrap="none" lIns="0" rIns="0" tIns="0" bIns="0">
+          <a:bodyPr wrap="none" lIns="0" tIns="0" rIns="0" bIns="0">
             <a:spAutoFit/>
           </a:bodyPr>
           <a:lstStyle/>
@@ -9057,7 +9112,7 @@
           </a:fontRef>
         </p:style>
         <p:txBody>
-          <a:bodyPr rtlCol="0" anchor="ctr" wrap="square" lIns="73152" rIns="73152" tIns="54864" bIns="54864"/>
+          <a:bodyPr wrap="square" lIns="73152" tIns="54864" rIns="73152" bIns="54864" rtlCol="0" anchor="ctr"/>
           <a:lstStyle/>
           <a:p>
             <a:pPr algn="ctr">
@@ -9067,7 +9122,7 @@
               <a:buNone/>
             </a:pPr>
             <a:r>
-              <a:rPr sz="950" b="1">
+              <a:rPr sz="1400" b="1" dirty="0">
                 <a:solidFill>
                   <a:srgbClr val="D75F00"/>
                 </a:solidFill>
@@ -9083,7 +9138,7 @@
               <a:buNone/>
             </a:pPr>
             <a:r>
-              <a:rPr sz="800" b="0">
+              <a:rPr sz="1400" b="0" dirty="0">
                 <a:solidFill>
                   <a:srgbClr val="2D2D2D"/>
                 </a:solidFill>
@@ -9099,7 +9154,7 @@
               <a:buNone/>
             </a:pPr>
             <a:r>
-              <a:rPr sz="800" b="0">
+              <a:rPr sz="1400" b="0" dirty="0">
                 <a:solidFill>
                   <a:srgbClr val="2D2D2D"/>
                 </a:solidFill>
@@ -9115,12 +9170,28 @@
               <a:buNone/>
             </a:pPr>
             <a:r>
-              <a:rPr sz="800" b="0">
-                <a:solidFill>
-                  <a:srgbClr val="2D2D2D"/>
-                </a:solidFill>
-              </a:rPr>
-              <a:t>• DigiLocker 1-Citizen-1-Vote</a:t>
+              <a:rPr sz="1400" b="0" dirty="0">
+                <a:solidFill>
+                  <a:srgbClr val="2D2D2D"/>
+                </a:solidFill>
+              </a:rPr>
+              <a:t>• </a:t>
+            </a:r>
+            <a:r>
+              <a:rPr sz="1400" b="0" dirty="0" err="1">
+                <a:solidFill>
+                  <a:srgbClr val="2D2D2D"/>
+                </a:solidFill>
+              </a:rPr>
+              <a:t>DigiLocker</a:t>
+            </a:r>
+            <a:r>
+              <a:rPr sz="1400" b="0" dirty="0">
+                <a:solidFill>
+                  <a:srgbClr val="2D2D2D"/>
+                </a:solidFill>
+              </a:rPr>
+              <a:t> 1-Citizen-1-Vote</a:t>
             </a:r>
           </a:p>
           <a:p>
@@ -9131,7 +9202,7 @@
               <a:buNone/>
             </a:pPr>
             <a:r>
-              <a:rPr sz="800" b="0">
+              <a:rPr sz="1400" b="0" dirty="0">
                 <a:solidFill>
                   <a:srgbClr val="2D2D2D"/>
                 </a:solidFill>
@@ -9158,7 +9229,7 @@
           <a:noFill/>
         </p:spPr>
         <p:txBody>
-          <a:bodyPr wrap="none" lIns="0" rIns="0" tIns="0" bIns="0">
+          <a:bodyPr wrap="none" lIns="0" tIns="0" rIns="0" bIns="0">
             <a:spAutoFit/>
           </a:bodyPr>
           <a:lstStyle/>
@@ -9215,7 +9286,7 @@
           </a:fontRef>
         </p:style>
         <p:txBody>
-          <a:bodyPr rtlCol="0" anchor="ctr" wrap="square" lIns="73152" rIns="73152" tIns="54864" bIns="54864"/>
+          <a:bodyPr wrap="square" lIns="73152" tIns="54864" rIns="73152" bIns="54864" rtlCol="0" anchor="ctr"/>
           <a:lstStyle/>
           <a:p>
             <a:pPr algn="ctr">
@@ -9225,7 +9296,7 @@
               <a:buNone/>
             </a:pPr>
             <a:r>
-              <a:rPr sz="950" b="1">
+              <a:rPr sz="1400" b="1" dirty="0">
                 <a:solidFill>
                   <a:srgbClr val="822882"/>
                 </a:solidFill>
@@ -9241,7 +9312,7 @@
               <a:buNone/>
             </a:pPr>
             <a:r>
-              <a:rPr sz="800" b="0">
+              <a:rPr sz="1400" b="0" dirty="0">
                 <a:solidFill>
                   <a:srgbClr val="2D2D2D"/>
                 </a:solidFill>
@@ -9257,7 +9328,7 @@
               <a:buNone/>
             </a:pPr>
             <a:r>
-              <a:rPr sz="800" b="0">
+              <a:rPr sz="1400" b="0" dirty="0">
                 <a:solidFill>
                   <a:srgbClr val="2D2D2D"/>
                 </a:solidFill>
@@ -9273,7 +9344,7 @@
               <a:buNone/>
             </a:pPr>
             <a:r>
-              <a:rPr sz="800" b="0">
+              <a:rPr sz="1400" b="0" dirty="0">
                 <a:solidFill>
                   <a:srgbClr val="2D2D2D"/>
                 </a:solidFill>
@@ -9289,7 +9360,7 @@
               <a:buNone/>
             </a:pPr>
             <a:r>
-              <a:rPr sz="800" b="0">
+              <a:rPr sz="1400" b="0" dirty="0">
                 <a:solidFill>
                   <a:srgbClr val="2D2D2D"/>
                 </a:solidFill>
@@ -9331,85 +9402,6 @@
       </p:grpSpPr>
       <p:sp>
         <p:nvSpPr>
-          <p:cNvPr id="10" name="Rectangle 9">
-            <a:extLst>
-              <a:ext uri="{FF2B5EF4-FFF2-40B4-BE49-F238E27FC236}">
-                <a16:creationId xmlns:a16="http://schemas.microsoft.com/office/drawing/2014/main" id="{AD4F69D3-EEB0-4C4C-9434-B9960FB5854C}"/>
-              </a:ext>
-            </a:extLst>
-          </p:cNvPr>
-          <p:cNvSpPr>
-            <a:spLocks noChangeArrowheads="1"/>
-          </p:cNvSpPr>
-          <p:nvPr/>
-        </p:nvSpPr>
-        <p:spPr bwMode="auto">
-          <a:xfrm>
-            <a:off x="0" y="6354762"/>
-            <a:ext cx="12191999" cy="503238"/>
-          </a:xfrm>
-          <a:prstGeom prst="rect">
-            <a:avLst/>
-          </a:prstGeom>
-          <a:solidFill>
-            <a:srgbClr val="0070C0"/>
-          </a:solidFill>
-          <a:ln w="9525">
-            <a:noFill/>
-            <a:miter lim="800000"/>
-            <a:headEnd/>
-            <a:tailEnd/>
-          </a:ln>
-          <a:effectLst>
-            <a:outerShdw dist="23000" dir="5400000" rotWithShape="0">
-              <a:srgbClr val="808080">
-                <a:alpha val="34999"/>
-              </a:srgbClr>
-            </a:outerShdw>
-          </a:effectLst>
-        </p:spPr>
-        <p:txBody>
-          <a:bodyPr anchor="ctr"/>
-          <a:lstStyle/>
-          <a:p>
-            <a:pPr marL="0" marR="0" lvl="0" indent="0" algn="ctr" defTabSz="457200" rtl="0" eaLnBrk="1" fontAlgn="auto" latinLnBrk="0" hangingPunct="1">
-              <a:lnSpc>
-                <a:spcPct val="100000"/>
-              </a:lnSpc>
-              <a:spcBef>
-                <a:spcPts val="0"/>
-              </a:spcBef>
-              <a:spcAft>
-                <a:spcPts val="0"/>
-              </a:spcAft>
-              <a:buClrTx/>
-              <a:buSzTx/>
-              <a:buFontTx/>
-              <a:buNone/>
-              <a:tabLst/>
-              <a:defRPr/>
-            </a:pPr>
-            <a:endParaRPr kumimoji="0" lang="en-US" sz="1800" b="0" i="0" u="none" strike="noStrike" kern="1200" cap="none" spc="0" normalizeH="0" baseline="0" noProof="0" dirty="0">
-              <a:ln>
-                <a:noFill/>
-              </a:ln>
-              <a:solidFill>
-                <a:srgbClr val="C0504D">
-                  <a:lumMod val="75000"/>
-                </a:srgbClr>
-              </a:solidFill>
-              <a:effectLst/>
-              <a:uLnTx/>
-              <a:uFillTx/>
-              <a:latin typeface="Calibri"/>
-              <a:ea typeface="ＭＳ Ｐゴシック" pitchFamily="1" charset="-128"/>
-              <a:cs typeface="+mn-cs"/>
-            </a:endParaRPr>
-          </a:p>
-        </p:txBody>
-      </p:sp>
-      <p:sp>
-        <p:nvSpPr>
           <p:cNvPr id="17409" name="Title 1"/>
           <p:cNvSpPr>
             <a:spLocks noGrp="1"/>
@@ -9446,7 +9438,7 @@
         <p:spPr bwMode="auto">
           <a:xfrm>
             <a:off x="612648" y="1207008"/>
-            <a:ext cx="10972800" cy="3017520"/>
+            <a:ext cx="10972800" cy="3574825"/>
           </a:xfrm>
           <a:prstGeom prst="rect">
             <a:avLst/>
@@ -9460,7 +9452,7 @@
           </a:ln>
         </p:spPr>
         <p:txBody>
-          <a:bodyPr wrap="square" lIns="45720" rIns="45720" tIns="36576" bIns="36576">
+          <a:bodyPr wrap="square" lIns="45720" tIns="36576" rIns="45720" bIns="36576">
             <a:spAutoFit/>
           </a:bodyPr>
           <a:lstStyle/>
@@ -9479,10 +9471,9 @@
               <a:buSzTx/>
               <a:tabLst/>
               <a:defRPr/>
-              <a:buNone/>
-            </a:pPr>
-            <a:r>
-              <a:rPr sz="1050" b="1">
+            </a:pPr>
+            <a:r>
+              <a:rPr sz="2000" b="1" dirty="0">
                 <a:solidFill>
                   <a:srgbClr val="003C82"/>
                 </a:solidFill>
@@ -9501,12 +9492,20 @@
               <a:buNone/>
             </a:pPr>
             <a:r>
-              <a:rPr sz="900" b="0">
-                <a:solidFill>
-                  <a:srgbClr val="2D2D2D"/>
-                </a:solidFill>
-              </a:rPr>
-              <a:t>  • 96 Crore Registered Voters: Enables instant 10-second candidate audits before voting — ending democratic information asymmetry.</a:t>
+              <a:rPr sz="900" b="0" dirty="0">
+                <a:solidFill>
+                  <a:srgbClr val="2D2D2D"/>
+                </a:solidFill>
+              </a:rPr>
+              <a:t>  </a:t>
+            </a:r>
+            <a:r>
+              <a:rPr sz="1700" b="0" dirty="0">
+                <a:solidFill>
+                  <a:srgbClr val="2D2D2D"/>
+                </a:solidFill>
+              </a:rPr>
+              <a:t>• 96 Crore Registered Voters: Enables instant 10-second candidate audits before voting — ending democratic information asymmetry.</a:t>
             </a:r>
           </a:p>
           <a:p>
@@ -9520,7 +9519,7 @@
               <a:buNone/>
             </a:pPr>
             <a:r>
-              <a:rPr sz="900" b="0">
+              <a:rPr sz="1700" b="0" dirty="0">
                 <a:solidFill>
                   <a:srgbClr val="2D2D2D"/>
                 </a:solidFill>
@@ -9539,7 +9538,7 @@
               <a:buNone/>
             </a:pPr>
             <a:r>
-              <a:rPr sz="900" b="0">
+              <a:rPr sz="1700" b="0" dirty="0">
                 <a:solidFill>
                   <a:srgbClr val="2D2D2D"/>
                 </a:solidFill>
@@ -9558,7 +9557,7 @@
               <a:buNone/>
             </a:pPr>
             <a:r>
-              <a:rPr sz="900" b="0">
+              <a:rPr sz="1700" b="0" dirty="0">
                 <a:solidFill>
                   <a:srgbClr val="2D2D2D"/>
                 </a:solidFill>
@@ -9577,7 +9576,7 @@
               <a:buNone/>
             </a:pPr>
             <a:r>
-              <a:rPr sz="1050" b="1">
+              <a:rPr sz="2000" b="1" dirty="0">
                 <a:solidFill>
                   <a:srgbClr val="003C82"/>
                 </a:solidFill>
@@ -9596,7 +9595,7 @@
               <a:buNone/>
             </a:pPr>
             <a:r>
-              <a:rPr sz="900" b="0">
+              <a:rPr sz="1700" b="0" dirty="0">
                 <a:solidFill>
                   <a:srgbClr val="2D2D2D"/>
                 </a:solidFill>
@@ -9615,7 +9614,7 @@
               <a:buNone/>
             </a:pPr>
             <a:r>
-              <a:rPr sz="900" b="0">
+              <a:rPr sz="1700" b="0" dirty="0">
                 <a:solidFill>
                   <a:srgbClr val="2D2D2D"/>
                 </a:solidFill>
@@ -9634,7 +9633,7 @@
               <a:buNone/>
             </a:pPr>
             <a:r>
-              <a:rPr sz="900" b="0">
+              <a:rPr sz="1700" b="0" dirty="0">
                 <a:solidFill>
                   <a:srgbClr val="2D2D2D"/>
                 </a:solidFill>
@@ -9765,7 +9764,7 @@
               <a:defRPr/>
             </a:pPr>
             <a:r>
-              <a:rPr kumimoji="0" lang="en-US" sz="1200" b="0" i="0" u="none" strike="noStrike" kern="1200" cap="none" spc="0" normalizeH="0" baseline="0" noProof="0">
+              <a:rPr kumimoji="0" lang="en-US" sz="1200" b="0" i="0" u="none" strike="noStrike" kern="1200" cap="none" spc="0" normalizeH="0" baseline="0" noProof="0" dirty="0">
                 <a:ln>
                   <a:noFill/>
                 </a:ln>
@@ -9781,20 +9780,6 @@
               </a:rPr>
               <a:t>@SIH Idea submission- Template</a:t>
             </a:r>
-            <a:endParaRPr kumimoji="0" lang="en-US" sz="1200" b="0" i="0" u="none" strike="noStrike" kern="1200" cap="none" spc="0" normalizeH="0" baseline="0" noProof="0" dirty="0">
-              <a:ln>
-                <a:noFill/>
-              </a:ln>
-              <a:solidFill>
-                <a:prstClr val="white"/>
-              </a:solidFill>
-              <a:effectLst/>
-              <a:uLnTx/>
-              <a:uFillTx/>
-              <a:latin typeface="TradeGothic"/>
-              <a:ea typeface="+mn-ea"/>
-              <a:cs typeface="+mn-cs"/>
-            </a:endParaRPr>
           </a:p>
         </p:txBody>
       </p:sp>
@@ -9806,7 +9791,7 @@
                 <a16:creationId xmlns:a16="http://schemas.microsoft.com/office/drawing/2014/main" id="{5DBCE864-823D-4A13-9607-5DA1F0ED5FB8}"/>
               </a:ext>
               <a:ext uri="{C183D7F6-B498-43B3-948B-1728B52AA6E4}">
-                <adec:decorative xmlns:adec="http://schemas.microsoft.com/office/drawing/2017/decorative" xmlns="" val="0"/>
+                <adec:decorative xmlns:adec="http://schemas.microsoft.com/office/drawing/2017/decorative" val="0"/>
               </a:ext>
             </a:extLst>
           </p:cNvPr>
@@ -9901,7 +9886,7 @@
         </p:nvSpPr>
         <p:spPr>
           <a:xfrm>
-            <a:off x="612648" y="4343400"/>
+            <a:off x="612648" y="5012266"/>
             <a:ext cx="2578608" cy="1508760"/>
           </a:xfrm>
           <a:prstGeom prst="roundRect">
@@ -9931,7 +9916,7 @@
           </a:fontRef>
         </p:style>
         <p:txBody>
-          <a:bodyPr rtlCol="0" anchor="ctr" wrap="square" lIns="73152" rIns="73152" tIns="54864" bIns="54864"/>
+          <a:bodyPr wrap="square" lIns="73152" tIns="54864" rIns="73152" bIns="54864" rtlCol="0" anchor="ctr"/>
           <a:lstStyle/>
           <a:p>
             <a:pPr algn="ctr">
@@ -9941,7 +9926,7 @@
               <a:buNone/>
             </a:pPr>
             <a:r>
-              <a:rPr sz="1000" b="1">
+              <a:rPr sz="1400" b="1" dirty="0">
                 <a:solidFill>
                   <a:srgbClr val="0050A0"/>
                 </a:solidFill>
@@ -9957,7 +9942,7 @@
               <a:buNone/>
             </a:pPr>
             <a:r>
-              <a:rPr sz="800" b="0">
+              <a:rPr sz="1400" b="0" dirty="0">
                 <a:solidFill>
                   <a:srgbClr val="2D2D2D"/>
                 </a:solidFill>
@@ -9973,7 +9958,7 @@
               <a:buNone/>
             </a:pPr>
             <a:r>
-              <a:rPr sz="800" b="0">
+              <a:rPr sz="1400" b="0" dirty="0">
                 <a:solidFill>
                   <a:srgbClr val="2D2D2D"/>
                 </a:solidFill>
@@ -9989,7 +9974,7 @@
               <a:buNone/>
             </a:pPr>
             <a:r>
-              <a:rPr sz="800" b="0">
+              <a:rPr sz="1400" b="0" dirty="0">
                 <a:solidFill>
                   <a:srgbClr val="2D2D2D"/>
                 </a:solidFill>
@@ -10007,7 +9992,7 @@
         </p:nvSpPr>
         <p:spPr>
           <a:xfrm>
-            <a:off x="3392424" y="4343400"/>
+            <a:off x="3392424" y="5012266"/>
             <a:ext cx="2578608" cy="1508760"/>
           </a:xfrm>
           <a:prstGeom prst="roundRect">
@@ -10037,7 +10022,7 @@
           </a:fontRef>
         </p:style>
         <p:txBody>
-          <a:bodyPr rtlCol="0" anchor="ctr" wrap="square" lIns="73152" rIns="73152" tIns="54864" bIns="54864"/>
+          <a:bodyPr wrap="square" lIns="73152" tIns="54864" rIns="73152" bIns="54864" rtlCol="0" anchor="ctr"/>
           <a:lstStyle/>
           <a:p>
             <a:pPr algn="ctr">
@@ -10047,7 +10032,7 @@
               <a:buNone/>
             </a:pPr>
             <a:r>
-              <a:rPr sz="1000" b="1">
+              <a:rPr sz="1400" b="1" dirty="0">
                 <a:solidFill>
                   <a:srgbClr val="00823C"/>
                 </a:solidFill>
@@ -10063,7 +10048,7 @@
               <a:buNone/>
             </a:pPr>
             <a:r>
-              <a:rPr sz="800" b="0">
+              <a:rPr sz="1400" b="0" dirty="0">
                 <a:solidFill>
                   <a:srgbClr val="2D2D2D"/>
                 </a:solidFill>
@@ -10079,7 +10064,7 @@
               <a:buNone/>
             </a:pPr>
             <a:r>
-              <a:rPr sz="800" b="0">
+              <a:rPr sz="1400" b="0" dirty="0">
                 <a:solidFill>
                   <a:srgbClr val="2D2D2D"/>
                 </a:solidFill>
@@ -10095,7 +10080,7 @@
               <a:buNone/>
             </a:pPr>
             <a:r>
-              <a:rPr sz="800" b="0">
+              <a:rPr sz="1400" b="0" dirty="0">
                 <a:solidFill>
                   <a:srgbClr val="2D2D2D"/>
                 </a:solidFill>
@@ -10113,7 +10098,7 @@
         </p:nvSpPr>
         <p:spPr>
           <a:xfrm>
-            <a:off x="6172200" y="4343400"/>
+            <a:off x="6172200" y="5012266"/>
             <a:ext cx="2578608" cy="1508760"/>
           </a:xfrm>
           <a:prstGeom prst="roundRect">
@@ -10143,7 +10128,7 @@
           </a:fontRef>
         </p:style>
         <p:txBody>
-          <a:bodyPr rtlCol="0" anchor="ctr" wrap="square" lIns="73152" rIns="73152" tIns="54864" bIns="54864"/>
+          <a:bodyPr wrap="square" lIns="73152" tIns="54864" rIns="73152" bIns="54864" rtlCol="0" anchor="ctr"/>
           <a:lstStyle/>
           <a:p>
             <a:pPr algn="ctr">
@@ -10153,7 +10138,7 @@
               <a:buNone/>
             </a:pPr>
             <a:r>
-              <a:rPr sz="1000" b="1">
+              <a:rPr sz="1400" b="1" dirty="0">
                 <a:solidFill>
                   <a:srgbClr val="C82D2D"/>
                 </a:solidFill>
@@ -10169,7 +10154,7 @@
               <a:buNone/>
             </a:pPr>
             <a:r>
-              <a:rPr sz="800" b="0">
+              <a:rPr sz="1400" b="0" dirty="0">
                 <a:solidFill>
                   <a:srgbClr val="2D2D2D"/>
                 </a:solidFill>
@@ -10185,7 +10170,7 @@
               <a:buNone/>
             </a:pPr>
             <a:r>
-              <a:rPr sz="800" b="0">
+              <a:rPr sz="1400" b="0" dirty="0">
                 <a:solidFill>
                   <a:srgbClr val="2D2D2D"/>
                 </a:solidFill>
@@ -10201,7 +10186,7 @@
               <a:buNone/>
             </a:pPr>
             <a:r>
-              <a:rPr sz="800" b="0">
+              <a:rPr sz="1400" b="0" dirty="0">
                 <a:solidFill>
                   <a:srgbClr val="2D2D2D"/>
                 </a:solidFill>
@@ -10219,7 +10204,7 @@
         </p:nvSpPr>
         <p:spPr>
           <a:xfrm>
-            <a:off x="8951976" y="4343400"/>
+            <a:off x="8951976" y="5012266"/>
             <a:ext cx="2578608" cy="1508760"/>
           </a:xfrm>
           <a:prstGeom prst="roundRect">
@@ -10249,7 +10234,7 @@
           </a:fontRef>
         </p:style>
         <p:txBody>
-          <a:bodyPr rtlCol="0" anchor="ctr" wrap="square" lIns="73152" rIns="73152" tIns="54864" bIns="54864"/>
+          <a:bodyPr wrap="square" lIns="73152" tIns="54864" rIns="73152" bIns="54864" rtlCol="0" anchor="ctr"/>
           <a:lstStyle/>
           <a:p>
             <a:pPr algn="ctr">
@@ -10259,7 +10244,7 @@
               <a:buNone/>
             </a:pPr>
             <a:r>
-              <a:rPr sz="1000" b="1">
+              <a:rPr sz="1400" b="1" dirty="0">
                 <a:solidFill>
                   <a:srgbClr val="B45A00"/>
                 </a:solidFill>
@@ -10275,7 +10260,7 @@
               <a:buNone/>
             </a:pPr>
             <a:r>
-              <a:rPr sz="800" b="0">
+              <a:rPr sz="1400" b="0" dirty="0">
                 <a:solidFill>
                   <a:srgbClr val="2D2D2D"/>
                 </a:solidFill>
@@ -10291,7 +10276,7 @@
               <a:buNone/>
             </a:pPr>
             <a:r>
-              <a:rPr sz="800" b="0">
+              <a:rPr sz="1400" b="0" dirty="0">
                 <a:solidFill>
                   <a:srgbClr val="2D2D2D"/>
                 </a:solidFill>
@@ -10307,7 +10292,7 @@
               <a:buNone/>
             </a:pPr>
             <a:r>
-              <a:rPr sz="800" b="0">
+              <a:rPr sz="1400" b="0" dirty="0">
                 <a:solidFill>
                   <a:srgbClr val="2D2D2D"/>
                 </a:solidFill>
@@ -10349,85 +10334,6 @@
       </p:grpSpPr>
       <p:sp>
         <p:nvSpPr>
-          <p:cNvPr id="10" name="Rectangle 9">
-            <a:extLst>
-              <a:ext uri="{FF2B5EF4-FFF2-40B4-BE49-F238E27FC236}">
-                <a16:creationId xmlns:a16="http://schemas.microsoft.com/office/drawing/2014/main" id="{AD4F69D3-EEB0-4C4C-9434-B9960FB5854C}"/>
-              </a:ext>
-            </a:extLst>
-          </p:cNvPr>
-          <p:cNvSpPr>
-            <a:spLocks noChangeArrowheads="1"/>
-          </p:cNvSpPr>
-          <p:nvPr/>
-        </p:nvSpPr>
-        <p:spPr bwMode="auto">
-          <a:xfrm>
-            <a:off x="0" y="6354762"/>
-            <a:ext cx="12191999" cy="503238"/>
-          </a:xfrm>
-          <a:prstGeom prst="rect">
-            <a:avLst/>
-          </a:prstGeom>
-          <a:solidFill>
-            <a:srgbClr val="0070C0"/>
-          </a:solidFill>
-          <a:ln w="9525">
-            <a:noFill/>
-            <a:miter lim="800000"/>
-            <a:headEnd/>
-            <a:tailEnd/>
-          </a:ln>
-          <a:effectLst>
-            <a:outerShdw dist="23000" dir="5400000" rotWithShape="0">
-              <a:srgbClr val="808080">
-                <a:alpha val="34999"/>
-              </a:srgbClr>
-            </a:outerShdw>
-          </a:effectLst>
-        </p:spPr>
-        <p:txBody>
-          <a:bodyPr anchor="ctr"/>
-          <a:lstStyle/>
-          <a:p>
-            <a:pPr marL="0" marR="0" lvl="0" indent="0" algn="ctr" defTabSz="457200" rtl="0" eaLnBrk="1" fontAlgn="auto" latinLnBrk="0" hangingPunct="1">
-              <a:lnSpc>
-                <a:spcPct val="100000"/>
-              </a:lnSpc>
-              <a:spcBef>
-                <a:spcPts val="0"/>
-              </a:spcBef>
-              <a:spcAft>
-                <a:spcPts val="0"/>
-              </a:spcAft>
-              <a:buClrTx/>
-              <a:buSzTx/>
-              <a:buFontTx/>
-              <a:buNone/>
-              <a:tabLst/>
-              <a:defRPr/>
-            </a:pPr>
-            <a:endParaRPr kumimoji="0" lang="en-US" sz="1800" b="0" i="0" u="none" strike="noStrike" kern="1200" cap="none" spc="0" normalizeH="0" baseline="0" noProof="0" dirty="0">
-              <a:ln>
-                <a:noFill/>
-              </a:ln>
-              <a:solidFill>
-                <a:srgbClr val="C0504D">
-                  <a:lumMod val="75000"/>
-                </a:srgbClr>
-              </a:solidFill>
-              <a:effectLst/>
-              <a:uLnTx/>
-              <a:uFillTx/>
-              <a:latin typeface="Calibri"/>
-              <a:ea typeface="ＭＳ Ｐゴシック" pitchFamily="1" charset="-128"/>
-              <a:cs typeface="+mn-cs"/>
-            </a:endParaRPr>
-          </a:p>
-        </p:txBody>
-      </p:sp>
-      <p:sp>
-        <p:nvSpPr>
           <p:cNvPr id="17409" name="Title 1"/>
           <p:cNvSpPr>
             <a:spLocks noGrp="1"/>
@@ -10463,8 +10369,8 @@
         </p:nvSpPr>
         <p:spPr bwMode="auto">
           <a:xfrm>
-            <a:off x="612648" y="1207008"/>
-            <a:ext cx="10972800" cy="3017520"/>
+            <a:off x="1057136" y="1154303"/>
+            <a:ext cx="10972800" cy="3492751"/>
           </a:xfrm>
           <a:prstGeom prst="rect">
             <a:avLst/>
@@ -10478,7 +10384,7 @@
           </a:ln>
         </p:spPr>
         <p:txBody>
-          <a:bodyPr wrap="square" lIns="45720" rIns="45720" tIns="36576" bIns="36576">
+          <a:bodyPr wrap="square" lIns="45720" tIns="36576" rIns="45720" bIns="36576">
             <a:spAutoFit/>
           </a:bodyPr>
           <a:lstStyle/>
@@ -10497,17 +10403,16 @@
               <a:buSzTx/>
               <a:tabLst/>
               <a:defRPr/>
-              <a:buNone/>
-            </a:pPr>
-            <a:r>
-              <a:rPr sz="1050" b="1">
+            </a:pPr>
+            <a:r>
+              <a:rPr sz="2000" b="1" dirty="0">
                 <a:solidFill>
                   <a:srgbClr val="003C82"/>
                 </a:solidFill>
               </a:rPr>
               <a:t>OFFICIAL GOVERNMENT DATA SOURCES &amp; STATUTORY REFERENCES:</a:t>
             </a:r>
-            <a:endParaRPr kumimoji="0" lang="en-US" sz="2800" b="0" i="0" u="none" strike="noStrike" kern="1200" cap="none" spc="0" normalizeH="0" baseline="0" noProof="0" dirty="0">
+            <a:endParaRPr kumimoji="0" lang="en-US" sz="2000" b="0" i="0" u="none" strike="noStrike" kern="1200" cap="none" spc="0" normalizeH="0" baseline="0" noProof="0" dirty="0">
               <a:ln>
                 <a:noFill/>
               </a:ln>
@@ -10533,12 +10438,28 @@
               <a:buNone/>
             </a:pPr>
             <a:r>
-              <a:rPr sz="900" b="0">
-                <a:solidFill>
-                  <a:srgbClr val="2D2D2D"/>
-                </a:solidFill>
-              </a:rPr>
-              <a:t>  • Election Commission of India (ECI): Form 26 candidate affidavits, assets &amp; education declarations (affidavit.eci.gov.in)</a:t>
+              <a:rPr sz="900" b="0" dirty="0">
+                <a:solidFill>
+                  <a:srgbClr val="2D2D2D"/>
+                </a:solidFill>
+              </a:rPr>
+              <a:t> </a:t>
+            </a:r>
+            <a:r>
+              <a:rPr sz="1700" b="0" dirty="0">
+                <a:solidFill>
+                  <a:srgbClr val="2D2D2D"/>
+                </a:solidFill>
+              </a:rPr>
+              <a:t> </a:t>
+            </a:r>
+            <a:r>
+              <a:rPr sz="1600" b="0" dirty="0">
+                <a:solidFill>
+                  <a:srgbClr val="2D2D2D"/>
+                </a:solidFill>
+              </a:rPr>
+              <a:t>• Election Commission of India (ECI): Form 26 candidate affidavits, assets &amp; education declarations (affidavit.eci.gov.in)</a:t>
             </a:r>
           </a:p>
           <a:p>
@@ -10552,12 +10473,28 @@
               <a:buNone/>
             </a:pPr>
             <a:r>
-              <a:rPr sz="900" b="0">
-                <a:solidFill>
-                  <a:srgbClr val="2D2D2D"/>
-                </a:solidFill>
-              </a:rPr>
-              <a:t>  • National Judicial Data Grid (NJDG) / eCourts: Live district court case status, FIRs &amp; IPC sections (ecourts.gov.in)</a:t>
+              <a:rPr sz="1600" b="0" dirty="0">
+                <a:solidFill>
+                  <a:srgbClr val="2D2D2D"/>
+                </a:solidFill>
+              </a:rPr>
+              <a:t>  • National Judicial Data Grid (NJDG) / </a:t>
+            </a:r>
+            <a:r>
+              <a:rPr sz="1600" b="0" dirty="0" err="1">
+                <a:solidFill>
+                  <a:srgbClr val="2D2D2D"/>
+                </a:solidFill>
+              </a:rPr>
+              <a:t>eCourts</a:t>
+            </a:r>
+            <a:r>
+              <a:rPr sz="1600" b="0" dirty="0">
+                <a:solidFill>
+                  <a:srgbClr val="2D2D2D"/>
+                </a:solidFill>
+              </a:rPr>
+              <a:t>: Live district court case status, FIRs &amp; IPC sections (ecourts.gov.in)</a:t>
             </a:r>
           </a:p>
           <a:p>
@@ -10571,7 +10508,7 @@
               <a:buNone/>
             </a:pPr>
             <a:r>
-              <a:rPr sz="900" b="0">
+              <a:rPr sz="1600" b="0" dirty="0">
                 <a:solidFill>
                   <a:srgbClr val="2D2D2D"/>
                 </a:solidFill>
@@ -10590,7 +10527,7 @@
               <a:buNone/>
             </a:pPr>
             <a:r>
-              <a:rPr sz="900" b="0">
+              <a:rPr sz="1600" b="0" dirty="0">
                 <a:solidFill>
                   <a:srgbClr val="2D2D2D"/>
                 </a:solidFill>
@@ -10609,12 +10546,28 @@
               <a:buNone/>
             </a:pPr>
             <a:r>
-              <a:rPr sz="900" b="0">
-                <a:solidFill>
-                  <a:srgbClr val="2D2D2D"/>
-                </a:solidFill>
-              </a:rPr>
-              <a:t>  • Supreme Court of India: Landmark orders in WP(C) 318/2006 (BOCW Cess Fund) &amp; WP(C) 202/1995 (CAMPA Afforestation)</a:t>
+              <a:rPr sz="1600" b="0" dirty="0">
+                <a:solidFill>
+                  <a:srgbClr val="2D2D2D"/>
+                </a:solidFill>
+              </a:rPr>
+              <a:t>  • Supreme Court of India: Landmark orders in WP(C) 318/2006 (BOCW </a:t>
+            </a:r>
+            <a:r>
+              <a:rPr sz="1600" b="0" dirty="0" err="1">
+                <a:solidFill>
+                  <a:srgbClr val="2D2D2D"/>
+                </a:solidFill>
+              </a:rPr>
+              <a:t>Cess</a:t>
+            </a:r>
+            <a:r>
+              <a:rPr sz="1600" b="0" dirty="0">
+                <a:solidFill>
+                  <a:srgbClr val="2D2D2D"/>
+                </a:solidFill>
+              </a:rPr>
+              <a:t> Fund) &amp; WP(C) 202/1995 (CAMPA Afforestation)</a:t>
             </a:r>
           </a:p>
           <a:p>
@@ -10628,7 +10581,7 @@
               <a:buNone/>
             </a:pPr>
             <a:r>
-              <a:rPr sz="900" b="0">
+              <a:rPr sz="1600" b="0" dirty="0">
                 <a:solidFill>
                   <a:srgbClr val="2D2D2D"/>
                 </a:solidFill>
@@ -10647,13 +10600,18 @@
               <a:buNone/>
             </a:pPr>
             <a:r>
-              <a:rPr sz="1050" b="1">
+              <a:rPr sz="2000" b="1" dirty="0">
                 <a:solidFill>
                   <a:srgbClr val="003C82"/>
                 </a:solidFill>
               </a:rPr>
               <a:t>LIVE PLATFORM REPOSITORIES &amp; DOCUMENTATION:</a:t>
             </a:r>
+            <a:endParaRPr lang="fr-FR" sz="2000" b="1" dirty="0">
+              <a:solidFill>
+                <a:srgbClr val="003C82"/>
+              </a:solidFill>
+            </a:endParaRPr>
           </a:p>
           <a:p>
             <a:pPr>
@@ -10663,15 +10621,14 @@
               <a:spcAft>
                 <a:spcPts val="150"/>
               </a:spcAft>
-              <a:buNone/>
-            </a:pPr>
-            <a:r>
-              <a:rPr sz="900" b="0">
-                <a:solidFill>
-                  <a:srgbClr val="2D2D2D"/>
-                </a:solidFill>
-              </a:rPr>
-              <a:t>  • Live Production URL: https://verdict.vercel.app  |  Source Code: https://github.com/KATRIXBEE/verdict</a:t>
+            </a:pPr>
+            <a:r>
+              <a:rPr lang="fr-FR" sz="1700" b="0" dirty="0">
+                <a:solidFill>
+                  <a:srgbClr val="2D2D2D"/>
+                </a:solidFill>
+              </a:rPr>
+              <a:t>    Source Code: https://github.com/KATRIXBEE/verdict</a:t>
             </a:r>
           </a:p>
           <a:p>
@@ -10685,12 +10642,12 @@
               <a:buNone/>
             </a:pPr>
             <a:r>
-              <a:rPr sz="900" b="0">
-                <a:solidFill>
-                  <a:srgbClr val="2D2D2D"/>
-                </a:solidFill>
-              </a:rPr>
-              <a:t>  • Interactive REST API Docs: https://verdict.vercel.app/api-docs (OpenAPI / Swagger UI Documentation)</a:t>
+              <a:rPr sz="1700" b="0" dirty="0">
+                <a:solidFill>
+                  <a:srgbClr val="2D2D2D"/>
+                </a:solidFill>
+              </a:rPr>
+              <a:t>  </a:t>
             </a:r>
           </a:p>
         </p:txBody>
@@ -10857,7 +10814,7 @@
                 <a16:creationId xmlns:a16="http://schemas.microsoft.com/office/drawing/2014/main" id="{5DBCE864-823D-4A13-9607-5DA1F0ED5FB8}"/>
               </a:ext>
               <a:ext uri="{C183D7F6-B498-43B3-948B-1728B52AA6E4}">
-                <adec:decorative xmlns:adec="http://schemas.microsoft.com/office/drawing/2017/decorative" xmlns="" val="0"/>
+                <adec:decorative xmlns:adec="http://schemas.microsoft.com/office/drawing/2017/decorative" val="0"/>
               </a:ext>
             </a:extLst>
           </p:cNvPr>
@@ -10952,7 +10909,7 @@
         </p:nvSpPr>
         <p:spPr>
           <a:xfrm>
-            <a:off x="612648" y="4434840"/>
+            <a:off x="612648" y="5040757"/>
             <a:ext cx="2011680" cy="1325880"/>
           </a:xfrm>
           <a:prstGeom prst="roundRect">
@@ -10982,7 +10939,7 @@
           </a:fontRef>
         </p:style>
         <p:txBody>
-          <a:bodyPr rtlCol="0" anchor="ctr" wrap="square" lIns="73152" rIns="73152" tIns="54864" bIns="54864"/>
+          <a:bodyPr wrap="square" lIns="73152" tIns="54864" rIns="73152" bIns="54864" rtlCol="0" anchor="ctr"/>
           <a:lstStyle/>
           <a:p>
             <a:pPr algn="ctr">
@@ -10992,7 +10949,7 @@
               <a:buNone/>
             </a:pPr>
             <a:r>
-              <a:rPr sz="950" b="1">
+              <a:rPr sz="1400" b="1" dirty="0">
                 <a:solidFill>
                   <a:srgbClr val="0050A0"/>
                 </a:solidFill>
@@ -11008,7 +10965,7 @@
               <a:buNone/>
             </a:pPr>
             <a:r>
-              <a:rPr sz="750" b="0">
+              <a:rPr sz="1400" b="0" dirty="0">
                 <a:solidFill>
                   <a:srgbClr val="2D2D2D"/>
                 </a:solidFill>
@@ -11024,7 +10981,7 @@
               <a:buNone/>
             </a:pPr>
             <a:r>
-              <a:rPr sz="750" b="0">
+              <a:rPr sz="1400" b="0" dirty="0">
                 <a:solidFill>
                   <a:srgbClr val="2D2D2D"/>
                 </a:solidFill>
@@ -11040,7 +10997,7 @@
               <a:buNone/>
             </a:pPr>
             <a:r>
-              <a:rPr sz="750" b="0">
+              <a:rPr sz="1400" b="0" dirty="0">
                 <a:solidFill>
                   <a:srgbClr val="2D2D2D"/>
                 </a:solidFill>
@@ -11058,7 +11015,7 @@
         </p:nvSpPr>
         <p:spPr>
           <a:xfrm>
-            <a:off x="2852928" y="4434840"/>
+            <a:off x="2852928" y="5040757"/>
             <a:ext cx="2011680" cy="1325880"/>
           </a:xfrm>
           <a:prstGeom prst="roundRect">
@@ -11088,7 +11045,7 @@
           </a:fontRef>
         </p:style>
         <p:txBody>
-          <a:bodyPr rtlCol="0" anchor="ctr" wrap="square" lIns="73152" rIns="73152" tIns="54864" bIns="54864"/>
+          <a:bodyPr wrap="square" lIns="73152" tIns="54864" rIns="73152" bIns="54864" rtlCol="0" anchor="ctr"/>
           <a:lstStyle/>
           <a:p>
             <a:pPr algn="ctr">
@@ -11098,12 +11055,20 @@
               <a:buNone/>
             </a:pPr>
             <a:r>
-              <a:rPr sz="950" b="1">
+              <a:rPr sz="1400" b="1" dirty="0" err="1">
                 <a:solidFill>
                   <a:srgbClr val="00823C"/>
                 </a:solidFill>
               </a:rPr>
-              <a:t>eCourts Mapped</a:t>
+              <a:t>eCourts</a:t>
+            </a:r>
+            <a:r>
+              <a:rPr sz="1400" b="1" dirty="0">
+                <a:solidFill>
+                  <a:srgbClr val="00823C"/>
+                </a:solidFill>
+              </a:rPr>
+              <a:t> Mapped</a:t>
             </a:r>
           </a:p>
           <a:p>
@@ -11114,7 +11079,7 @@
               <a:buNone/>
             </a:pPr>
             <a:r>
-              <a:rPr sz="750" b="0">
+              <a:rPr sz="1400" b="0" dirty="0">
                 <a:solidFill>
                   <a:srgbClr val="2D2D2D"/>
                 </a:solidFill>
@@ -11130,7 +11095,7 @@
               <a:buNone/>
             </a:pPr>
             <a:r>
-              <a:rPr sz="750" b="0">
+              <a:rPr sz="1400" b="0" dirty="0">
                 <a:solidFill>
                   <a:srgbClr val="2D2D2D"/>
                 </a:solidFill>
@@ -11146,7 +11111,7 @@
               <a:buNone/>
             </a:pPr>
             <a:r>
-              <a:rPr sz="750" b="0">
+              <a:rPr sz="1400" b="0" dirty="0">
                 <a:solidFill>
                   <a:srgbClr val="2D2D2D"/>
                 </a:solidFill>
@@ -11164,7 +11129,7 @@
         </p:nvSpPr>
         <p:spPr>
           <a:xfrm>
-            <a:off x="5093208" y="4434840"/>
+            <a:off x="5093208" y="5040757"/>
             <a:ext cx="2011680" cy="1325880"/>
           </a:xfrm>
           <a:prstGeom prst="roundRect">
@@ -11194,7 +11159,7 @@
           </a:fontRef>
         </p:style>
         <p:txBody>
-          <a:bodyPr rtlCol="0" anchor="ctr" wrap="square" lIns="73152" rIns="73152" tIns="54864" bIns="54864"/>
+          <a:bodyPr wrap="square" lIns="73152" tIns="54864" rIns="73152" bIns="54864" rtlCol="0" anchor="ctr"/>
           <a:lstStyle/>
           <a:p>
             <a:pPr algn="ctr">
@@ -11204,7 +11169,7 @@
               <a:buNone/>
             </a:pPr>
             <a:r>
-              <a:rPr sz="950" b="1">
+              <a:rPr sz="1400" b="1" dirty="0">
                 <a:solidFill>
                   <a:srgbClr val="C82D2D"/>
                 </a:solidFill>
@@ -11220,7 +11185,7 @@
               <a:buNone/>
             </a:pPr>
             <a:r>
-              <a:rPr sz="750" b="0">
+              <a:rPr sz="1400" b="0" dirty="0">
                 <a:solidFill>
                   <a:srgbClr val="2D2D2D"/>
                 </a:solidFill>
@@ -11236,7 +11201,7 @@
               <a:buNone/>
             </a:pPr>
             <a:r>
-              <a:rPr sz="750" b="0">
+              <a:rPr sz="1400" b="0" dirty="0">
                 <a:solidFill>
                   <a:srgbClr val="2D2D2D"/>
                 </a:solidFill>
@@ -11252,7 +11217,7 @@
               <a:buNone/>
             </a:pPr>
             <a:r>
-              <a:rPr sz="750" b="0">
+              <a:rPr sz="1400" b="0" dirty="0">
                 <a:solidFill>
                   <a:srgbClr val="2D2D2D"/>
                 </a:solidFill>
@@ -11270,7 +11235,7 @@
         </p:nvSpPr>
         <p:spPr>
           <a:xfrm>
-            <a:off x="7333488" y="4434840"/>
+            <a:off x="7333488" y="5040757"/>
             <a:ext cx="2011680" cy="1325880"/>
           </a:xfrm>
           <a:prstGeom prst="roundRect">
@@ -11300,7 +11265,7 @@
           </a:fontRef>
         </p:style>
         <p:txBody>
-          <a:bodyPr rtlCol="0" anchor="ctr" wrap="square" lIns="73152" rIns="73152" tIns="54864" bIns="54864"/>
+          <a:bodyPr wrap="square" lIns="73152" tIns="54864" rIns="73152" bIns="54864" rtlCol="0" anchor="ctr"/>
           <a:lstStyle/>
           <a:p>
             <a:pPr algn="ctr">
@@ -11310,7 +11275,7 @@
               <a:buNone/>
             </a:pPr>
             <a:r>
-              <a:rPr sz="950" b="1">
+              <a:rPr sz="1400" b="1" dirty="0">
                 <a:solidFill>
                   <a:srgbClr val="B45A00"/>
                 </a:solidFill>
@@ -11326,7 +11291,7 @@
               <a:buNone/>
             </a:pPr>
             <a:r>
-              <a:rPr sz="750" b="0">
+              <a:rPr sz="1400" b="0" dirty="0">
                 <a:solidFill>
                   <a:srgbClr val="2D2D2D"/>
                 </a:solidFill>
@@ -11342,7 +11307,7 @@
               <a:buNone/>
             </a:pPr>
             <a:r>
-              <a:rPr sz="750" b="0">
+              <a:rPr sz="1400" b="0" dirty="0">
                 <a:solidFill>
                   <a:srgbClr val="2D2D2D"/>
                 </a:solidFill>
@@ -11358,7 +11323,7 @@
               <a:buNone/>
             </a:pPr>
             <a:r>
-              <a:rPr sz="750" b="0">
+              <a:rPr sz="1400" b="0" dirty="0">
                 <a:solidFill>
                   <a:srgbClr val="2D2D2D"/>
                 </a:solidFill>
@@ -11376,7 +11341,7 @@
         </p:nvSpPr>
         <p:spPr>
           <a:xfrm>
-            <a:off x="9573768" y="4434840"/>
+            <a:off x="9573768" y="5040757"/>
             <a:ext cx="2011680" cy="1325880"/>
           </a:xfrm>
           <a:prstGeom prst="roundRect">
@@ -11406,7 +11371,7 @@
           </a:fontRef>
         </p:style>
         <p:txBody>
-          <a:bodyPr rtlCol="0" anchor="ctr" wrap="square" lIns="73152" rIns="73152" tIns="54864" bIns="54864"/>
+          <a:bodyPr wrap="square" lIns="73152" tIns="54864" rIns="73152" bIns="54864" rtlCol="0" anchor="ctr"/>
           <a:lstStyle/>
           <a:p>
             <a:pPr algn="ctr">
@@ -11416,7 +11381,7 @@
               <a:buNone/>
             </a:pPr>
             <a:r>
-              <a:rPr sz="950" b="1">
+              <a:rPr sz="1400" b="1" dirty="0">
                 <a:solidFill>
                   <a:srgbClr val="64288C"/>
                 </a:solidFill>
@@ -11432,7 +11397,7 @@
               <a:buNone/>
             </a:pPr>
             <a:r>
-              <a:rPr sz="750" b="0">
+              <a:rPr sz="1400" b="0" dirty="0">
                 <a:solidFill>
                   <a:srgbClr val="2D2D2D"/>
                 </a:solidFill>
@@ -11448,7 +11413,7 @@
               <a:buNone/>
             </a:pPr>
             <a:r>
-              <a:rPr sz="750" b="0">
+              <a:rPr sz="1400" b="0" dirty="0">
                 <a:solidFill>
                   <a:srgbClr val="2D2D2D"/>
                 </a:solidFill>
@@ -11464,7 +11429,7 @@
               <a:buNone/>
             </a:pPr>
             <a:r>
-              <a:rPr sz="750" b="0">
+              <a:rPr sz="1400" b="0" dirty="0">
                 <a:solidFill>
                   <a:srgbClr val="2D2D2D"/>
                 </a:solidFill>
@@ -11478,859 +11443,6 @@
     <p:extLst>
       <p:ext uri="{BB962C8B-B14F-4D97-AF65-F5344CB8AC3E}">
         <p14:creationId xmlns:p14="http://schemas.microsoft.com/office/powerpoint/2010/main" val="3916788613"/>
-      </p:ext>
-    </p:extLst>
-  </p:cSld>
-  <p:clrMapOvr>
-    <a:masterClrMapping/>
-  </p:clrMapOvr>
-</p:sld>
-</file>
-
-<file path=ppt/slides/slide7.xml><?xml version="1.0" encoding="utf-8"?>
-<p:sld xmlns:a="http://schemas.openxmlformats.org/drawingml/2006/main" xmlns:r="http://schemas.openxmlformats.org/officeDocument/2006/relationships" xmlns:p="http://schemas.openxmlformats.org/presentationml/2006/main">
-  <p:cSld>
-    <p:spTree>
-      <p:nvGrpSpPr>
-        <p:cNvPr id="1" name=""/>
-        <p:cNvGrpSpPr/>
-        <p:nvPr/>
-      </p:nvGrpSpPr>
-      <p:grpSpPr>
-        <a:xfrm>
-          <a:off x="0" y="0"/>
-          <a:ext cx="0" cy="0"/>
-          <a:chOff x="0" y="0"/>
-          <a:chExt cx="0" cy="0"/>
-        </a:xfrm>
-      </p:grpSpPr>
-      <p:sp>
-        <p:nvSpPr>
-          <p:cNvPr id="10" name="Rectangle 9">
-            <a:extLst>
-              <a:ext uri="{FF2B5EF4-FFF2-40B4-BE49-F238E27FC236}">
-                <a16:creationId xmlns:a16="http://schemas.microsoft.com/office/drawing/2014/main" id="{AD4F69D3-EEB0-4C4C-9434-B9960FB5854C}"/>
-              </a:ext>
-            </a:extLst>
-          </p:cNvPr>
-          <p:cNvSpPr>
-            <a:spLocks noChangeArrowheads="1"/>
-          </p:cNvSpPr>
-          <p:nvPr/>
-        </p:nvSpPr>
-        <p:spPr bwMode="auto">
-          <a:xfrm>
-            <a:off x="0" y="6354762"/>
-            <a:ext cx="12191999" cy="503238"/>
-          </a:xfrm>
-          <a:prstGeom prst="rect">
-            <a:avLst/>
-          </a:prstGeom>
-          <a:solidFill>
-            <a:srgbClr val="0070C0"/>
-          </a:solidFill>
-          <a:ln w="9525">
-            <a:noFill/>
-            <a:miter lim="800000"/>
-            <a:headEnd/>
-            <a:tailEnd/>
-          </a:ln>
-          <a:effectLst>
-            <a:outerShdw dist="23000" dir="5400000" rotWithShape="0">
-              <a:srgbClr val="808080">
-                <a:alpha val="34999"/>
-              </a:srgbClr>
-            </a:outerShdw>
-          </a:effectLst>
-        </p:spPr>
-        <p:txBody>
-          <a:bodyPr anchor="ctr"/>
-          <a:lstStyle/>
-          <a:p>
-            <a:pPr marL="0" marR="0" lvl="0" indent="0" algn="ctr" defTabSz="457200" rtl="0" eaLnBrk="1" fontAlgn="auto" latinLnBrk="0" hangingPunct="1">
-              <a:lnSpc>
-                <a:spcPct val="100000"/>
-              </a:lnSpc>
-              <a:spcBef>
-                <a:spcPts val="0"/>
-              </a:spcBef>
-              <a:spcAft>
-                <a:spcPts val="0"/>
-              </a:spcAft>
-              <a:buClrTx/>
-              <a:buSzTx/>
-              <a:buFontTx/>
-              <a:buNone/>
-              <a:tabLst/>
-              <a:defRPr/>
-            </a:pPr>
-            <a:endParaRPr kumimoji="0" lang="en-US" sz="1800" b="0" i="0" u="none" strike="noStrike" kern="1200" cap="none" spc="0" normalizeH="0" baseline="0" noProof="0" dirty="0">
-              <a:ln>
-                <a:noFill/>
-              </a:ln>
-              <a:solidFill>
-                <a:srgbClr val="C0504D">
-                  <a:lumMod val="75000"/>
-                </a:srgbClr>
-              </a:solidFill>
-              <a:effectLst/>
-              <a:uLnTx/>
-              <a:uFillTx/>
-              <a:latin typeface="Calibri"/>
-              <a:ea typeface="ＭＳ Ｐゴシック" pitchFamily="1" charset="-128"/>
-              <a:cs typeface="+mn-cs"/>
-            </a:endParaRPr>
-          </a:p>
-        </p:txBody>
-      </p:sp>
-      <p:sp>
-        <p:nvSpPr>
-          <p:cNvPr id="6" name="Slide Number Placeholder 5"/>
-          <p:cNvSpPr>
-            <a:spLocks noGrp="1"/>
-          </p:cNvSpPr>
-          <p:nvPr>
-            <p:ph type="sldNum" sz="quarter" idx="12"/>
-          </p:nvPr>
-        </p:nvSpPr>
-        <p:spPr/>
-        <p:txBody>
-          <a:bodyPr/>
-          <a:lstStyle/>
-          <a:p>
-            <a:pPr marL="0" marR="0" lvl="0" indent="0" algn="r" defTabSz="457200" rtl="0" eaLnBrk="1" fontAlgn="base" latinLnBrk="0" hangingPunct="1">
-              <a:lnSpc>
-                <a:spcPct val="100000"/>
-              </a:lnSpc>
-              <a:spcBef>
-                <a:spcPct val="0"/>
-              </a:spcBef>
-              <a:spcAft>
-                <a:spcPct val="0"/>
-              </a:spcAft>
-              <a:buClrTx/>
-              <a:buSzTx/>
-              <a:buFontTx/>
-              <a:buNone/>
-              <a:tabLst/>
-              <a:defRPr/>
-            </a:pPr>
-            <a:fld id="{677C3CE7-23F7-4828-823C-E0205DF2CF97}" type="slidenum">
-              <a:rPr kumimoji="0" lang="en-US" sz="1200" b="1" i="0" u="none" strike="noStrike" kern="1200" cap="none" spc="0" normalizeH="0" baseline="0" noProof="0">
-                <a:ln>
-                  <a:noFill/>
-                </a:ln>
-                <a:solidFill>
-                  <a:prstClr val="white"/>
-                </a:solidFill>
-                <a:effectLst/>
-                <a:uLnTx/>
-                <a:uFillTx/>
-                <a:latin typeface="TradeGothic" pitchFamily="1" charset="0"/>
-                <a:ea typeface="ＭＳ Ｐゴシック" pitchFamily="1" charset="-128"/>
-                <a:cs typeface="+mn-cs"/>
-              </a:rPr>
-              <a:pPr marL="0" marR="0" lvl="0" indent="0" algn="r" defTabSz="457200" rtl="0" eaLnBrk="1" fontAlgn="base" latinLnBrk="0" hangingPunct="1">
-                <a:lnSpc>
-                  <a:spcPct val="100000"/>
-                </a:lnSpc>
-                <a:spcBef>
-                  <a:spcPct val="0"/>
-                </a:spcBef>
-                <a:spcAft>
-                  <a:spcPct val="0"/>
-                </a:spcAft>
-                <a:buClrTx/>
-                <a:buSzTx/>
-                <a:buFontTx/>
-                <a:buNone/>
-                <a:tabLst/>
-                <a:defRPr/>
-              </a:pPr>
-              <a:t>7</a:t>
-            </a:fld>
-            <a:endParaRPr kumimoji="0" lang="en-US" sz="1200" b="1" i="0" u="none" strike="noStrike" kern="1200" cap="none" spc="0" normalizeH="0" baseline="0" noProof="0" dirty="0">
-              <a:ln>
-                <a:noFill/>
-              </a:ln>
-              <a:solidFill>
-                <a:prstClr val="white"/>
-              </a:solidFill>
-              <a:effectLst/>
-              <a:uLnTx/>
-              <a:uFillTx/>
-              <a:latin typeface="TradeGothic" pitchFamily="1" charset="0"/>
-              <a:ea typeface="ＭＳ Ｐゴシック" pitchFamily="1" charset="-128"/>
-              <a:cs typeface="+mn-cs"/>
-            </a:endParaRPr>
-          </a:p>
-        </p:txBody>
-      </p:sp>
-      <p:sp>
-        <p:nvSpPr>
-          <p:cNvPr id="7" name="Footer Placeholder 6"/>
-          <p:cNvSpPr>
-            <a:spLocks noGrp="1"/>
-          </p:cNvSpPr>
-          <p:nvPr>
-            <p:ph type="ftr" sz="quarter" idx="11"/>
-          </p:nvPr>
-        </p:nvSpPr>
-        <p:spPr>
-          <a:xfrm>
-            <a:off x="4648200" y="6356353"/>
-            <a:ext cx="3204000" cy="365125"/>
-          </a:xfrm>
-        </p:spPr>
-        <p:txBody>
-          <a:bodyPr/>
-          <a:lstStyle/>
-          <a:p>
-            <a:pPr marL="0" marR="0" lvl="0" indent="0" algn="ctr" defTabSz="457200" rtl="0" eaLnBrk="1" fontAlgn="auto" latinLnBrk="0" hangingPunct="1">
-              <a:lnSpc>
-                <a:spcPct val="100000"/>
-              </a:lnSpc>
-              <a:spcBef>
-                <a:spcPts val="0"/>
-              </a:spcBef>
-              <a:spcAft>
-                <a:spcPts val="0"/>
-              </a:spcAft>
-              <a:buClrTx/>
-              <a:buSzTx/>
-              <a:buFontTx/>
-              <a:buNone/>
-              <a:tabLst/>
-              <a:defRPr/>
-            </a:pPr>
-            <a:r>
-              <a:rPr kumimoji="0" lang="en-US" sz="1200" b="0" i="0" u="none" strike="noStrike" kern="1200" cap="none" spc="0" normalizeH="0" baseline="0" noProof="0">
-                <a:ln>
-                  <a:noFill/>
-                </a:ln>
-                <a:solidFill>
-                  <a:prstClr val="white"/>
-                </a:solidFill>
-                <a:effectLst/>
-                <a:uLnTx/>
-                <a:uFillTx/>
-                <a:latin typeface="TradeGothic"/>
-                <a:ea typeface="+mn-ea"/>
-                <a:cs typeface="+mn-cs"/>
-              </a:rPr>
-              <a:t>@SIH Idea submission- Template</a:t>
-            </a:r>
-            <a:endParaRPr kumimoji="0" lang="en-US" sz="1200" b="0" i="0" u="none" strike="noStrike" kern="1200" cap="none" spc="0" normalizeH="0" baseline="0" noProof="0" dirty="0">
-              <a:ln>
-                <a:noFill/>
-              </a:ln>
-              <a:solidFill>
-                <a:prstClr val="white"/>
-              </a:solidFill>
-              <a:effectLst/>
-              <a:uLnTx/>
-              <a:uFillTx/>
-              <a:latin typeface="TradeGothic"/>
-              <a:ea typeface="+mn-ea"/>
-              <a:cs typeface="+mn-cs"/>
-            </a:endParaRPr>
-          </a:p>
-        </p:txBody>
-      </p:sp>
-      <p:sp>
-        <p:nvSpPr>
-          <p:cNvPr id="3" name="Round Diagonal Corner Rectangle 2"/>
-          <p:cNvSpPr/>
-          <p:nvPr/>
-        </p:nvSpPr>
-        <p:spPr>
-          <a:xfrm>
-            <a:off x="0" y="1791032"/>
-            <a:ext cx="12192000" cy="4319200"/>
-          </a:xfrm>
-          <a:prstGeom prst="round2DiagRect">
-            <a:avLst/>
-          </a:prstGeom>
-          <a:solidFill>
-            <a:schemeClr val="accent1">
-              <a:lumMod val="20000"/>
-              <a:lumOff val="80000"/>
-            </a:schemeClr>
-          </a:solidFill>
-          <a:ln w="38100"/>
-        </p:spPr>
-        <p:style>
-          <a:lnRef idx="1">
-            <a:schemeClr val="accent1"/>
-          </a:lnRef>
-          <a:fillRef idx="3">
-            <a:schemeClr val="accent1"/>
-          </a:fillRef>
-          <a:effectRef idx="2">
-            <a:schemeClr val="accent1"/>
-          </a:effectRef>
-          <a:fontRef idx="minor">
-            <a:schemeClr val="lt1"/>
-          </a:fontRef>
-        </p:style>
-        <p:txBody>
-          <a:bodyPr rtlCol="0" anchor="ctr"/>
-          <a:lstStyle/>
-          <a:p>
-            <a:pPr algn="ctr"/>
-            <a:endParaRPr lang="en-IN"/>
-          </a:p>
-        </p:txBody>
-      </p:sp>
-      <p:sp>
-        <p:nvSpPr>
-          <p:cNvPr id="12" name="Google Shape;100;p3"/>
-          <p:cNvSpPr txBox="1"/>
-          <p:nvPr/>
-        </p:nvSpPr>
-        <p:spPr>
-          <a:xfrm>
-            <a:off x="367832" y="1915454"/>
-            <a:ext cx="11764736" cy="4070356"/>
-          </a:xfrm>
-          <a:prstGeom prst="rect">
-            <a:avLst/>
-          </a:prstGeom>
-          <a:noFill/>
-          <a:ln>
-            <a:noFill/>
-          </a:ln>
-        </p:spPr>
-        <p:txBody>
-          <a:bodyPr spcFirstLastPara="1" wrap="square" lIns="91425" tIns="45700" rIns="91425" bIns="45700" anchor="t" anchorCtr="0">
-            <a:noAutofit/>
-          </a:bodyPr>
-          <a:lstStyle/>
-          <a:p>
-            <a:pPr marL="514350" marR="0" lvl="0" indent="-514350" algn="just" rtl="0">
-              <a:lnSpc>
-                <a:spcPct val="90000"/>
-              </a:lnSpc>
-              <a:spcBef>
-                <a:spcPts val="0"/>
-              </a:spcBef>
-              <a:spcAft>
-                <a:spcPts val="0"/>
-              </a:spcAft>
-              <a:buClr>
-                <a:schemeClr val="dk1"/>
-              </a:buClr>
-              <a:buSzPct val="100000"/>
-              <a:buFont typeface="Calibri"/>
-              <a:buAutoNum type="arabicPeriod"/>
-            </a:pPr>
-            <a:r>
-              <a:rPr lang="en-US" b="1" i="0" u="none" strike="noStrike" cap="none" dirty="0">
-                <a:solidFill>
-                  <a:schemeClr val="dk1"/>
-                </a:solidFill>
-                <a:latin typeface="Arial" panose="020B0604020202020204" pitchFamily="34" charset="0"/>
-                <a:ea typeface="Calibri"/>
-                <a:cs typeface="Arial" panose="020B0604020202020204" pitchFamily="34" charset="0"/>
-                <a:sym typeface="Calibri"/>
-              </a:rPr>
-              <a:t>Kindly keep the maximum slides limit up to six </a:t>
-            </a:r>
-            <a:r>
-              <a:rPr lang="en-US" b="1" i="0" u="none" strike="noStrike" cap="none" dirty="0">
-                <a:solidFill>
-                  <a:srgbClr val="C00000"/>
-                </a:solidFill>
-                <a:latin typeface="Arial" panose="020B0604020202020204" pitchFamily="34" charset="0"/>
-                <a:ea typeface="Calibri"/>
-                <a:cs typeface="Arial" panose="020B0604020202020204" pitchFamily="34" charset="0"/>
-                <a:sym typeface="Calibri"/>
-              </a:rPr>
-              <a:t>(6). </a:t>
-            </a:r>
-            <a:r>
-              <a:rPr lang="en-US" b="1" i="0" u="none" strike="noStrike" cap="none" dirty="0">
-                <a:solidFill>
-                  <a:schemeClr val="dk1"/>
-                </a:solidFill>
-                <a:latin typeface="Arial" panose="020B0604020202020204" pitchFamily="34" charset="0"/>
-                <a:ea typeface="Calibri"/>
-                <a:cs typeface="Arial" panose="020B0604020202020204" pitchFamily="34" charset="0"/>
-                <a:sym typeface="Calibri"/>
-              </a:rPr>
-              <a:t>( Including the </a:t>
-            </a:r>
-            <a:r>
-              <a:rPr lang="en-US" b="1" i="0" u="none" strike="noStrike" cap="none">
-                <a:solidFill>
-                  <a:schemeClr val="dk1"/>
-                </a:solidFill>
-                <a:latin typeface="Arial" panose="020B0604020202020204" pitchFamily="34" charset="0"/>
-                <a:ea typeface="Calibri"/>
-                <a:cs typeface="Arial" panose="020B0604020202020204" pitchFamily="34" charset="0"/>
-                <a:sym typeface="Calibri"/>
-              </a:rPr>
-              <a:t>title slide) </a:t>
-            </a:r>
-            <a:endParaRPr b="1" dirty="0">
-              <a:latin typeface="Arial" panose="020B0604020202020204" pitchFamily="34" charset="0"/>
-              <a:cs typeface="Arial" panose="020B0604020202020204" pitchFamily="34" charset="0"/>
-            </a:endParaRPr>
-          </a:p>
-          <a:p>
-            <a:pPr marL="514350" marR="0" lvl="0" indent="-514350" algn="just" rtl="0">
-              <a:lnSpc>
-                <a:spcPct val="90000"/>
-              </a:lnSpc>
-              <a:spcBef>
-                <a:spcPts val="1000"/>
-              </a:spcBef>
-              <a:spcAft>
-                <a:spcPts val="0"/>
-              </a:spcAft>
-              <a:buClr>
-                <a:schemeClr val="dk1"/>
-              </a:buClr>
-              <a:buSzPct val="100000"/>
-              <a:buFont typeface="Calibri"/>
-              <a:buAutoNum type="arabicPeriod"/>
-            </a:pPr>
-            <a:r>
-              <a:rPr lang="en-US" b="1" i="0" u="none" strike="noStrike" cap="none" dirty="0">
-                <a:solidFill>
-                  <a:schemeClr val="dk1"/>
-                </a:solidFill>
-                <a:latin typeface="Arial" panose="020B0604020202020204" pitchFamily="34" charset="0"/>
-                <a:ea typeface="Calibri"/>
-                <a:cs typeface="Arial" panose="020B0604020202020204" pitchFamily="34" charset="0"/>
-                <a:sym typeface="Calibri"/>
-              </a:rPr>
-              <a:t>Try to avoid paragraphs and post your idea in points /diagrams / Infographics /pictures </a:t>
-            </a:r>
-            <a:endParaRPr b="1" dirty="0">
-              <a:latin typeface="Arial" panose="020B0604020202020204" pitchFamily="34" charset="0"/>
-              <a:cs typeface="Arial" panose="020B0604020202020204" pitchFamily="34" charset="0"/>
-            </a:endParaRPr>
-          </a:p>
-          <a:p>
-            <a:pPr marL="514350" marR="0" lvl="0" indent="-514350" algn="just" rtl="0">
-              <a:lnSpc>
-                <a:spcPct val="90000"/>
-              </a:lnSpc>
-              <a:spcBef>
-                <a:spcPts val="1000"/>
-              </a:spcBef>
-              <a:spcAft>
-                <a:spcPts val="0"/>
-              </a:spcAft>
-              <a:buClr>
-                <a:schemeClr val="dk1"/>
-              </a:buClr>
-              <a:buSzPct val="100000"/>
-              <a:buFont typeface="Calibri"/>
-              <a:buAutoNum type="arabicPeriod"/>
-            </a:pPr>
-            <a:r>
-              <a:rPr lang="en-US" b="1" i="0" u="none" strike="noStrike" cap="none" dirty="0">
-                <a:solidFill>
-                  <a:schemeClr val="dk1"/>
-                </a:solidFill>
-                <a:latin typeface="Arial" panose="020B0604020202020204" pitchFamily="34" charset="0"/>
-                <a:ea typeface="Calibri"/>
-                <a:cs typeface="Arial" panose="020B0604020202020204" pitchFamily="34" charset="0"/>
-                <a:sym typeface="Calibri"/>
-              </a:rPr>
-              <a:t>Keep your explanation precise and easy to understand</a:t>
-            </a:r>
-            <a:endParaRPr b="1" dirty="0">
-              <a:latin typeface="Arial" panose="020B0604020202020204" pitchFamily="34" charset="0"/>
-              <a:cs typeface="Arial" panose="020B0604020202020204" pitchFamily="34" charset="0"/>
-            </a:endParaRPr>
-          </a:p>
-          <a:p>
-            <a:pPr marL="514350" marR="0" lvl="0" indent="-514350" algn="just" rtl="0">
-              <a:lnSpc>
-                <a:spcPct val="90000"/>
-              </a:lnSpc>
-              <a:spcBef>
-                <a:spcPts val="1000"/>
-              </a:spcBef>
-              <a:spcAft>
-                <a:spcPts val="0"/>
-              </a:spcAft>
-              <a:buClr>
-                <a:schemeClr val="dk1"/>
-              </a:buClr>
-              <a:buSzPct val="100000"/>
-              <a:buFont typeface="Calibri"/>
-              <a:buAutoNum type="arabicPeriod"/>
-            </a:pPr>
-            <a:r>
-              <a:rPr lang="en-US" b="1" i="0" u="none" strike="noStrike" cap="none" dirty="0">
-                <a:solidFill>
-                  <a:schemeClr val="dk1"/>
-                </a:solidFill>
-                <a:latin typeface="Arial" panose="020B0604020202020204" pitchFamily="34" charset="0"/>
-                <a:ea typeface="Calibri"/>
-                <a:cs typeface="Arial" panose="020B0604020202020204" pitchFamily="34" charset="0"/>
-                <a:sym typeface="Calibri"/>
-              </a:rPr>
-              <a:t>Idea should be unique and novel. </a:t>
-            </a:r>
-            <a:endParaRPr b="1" dirty="0">
-              <a:latin typeface="Arial" panose="020B0604020202020204" pitchFamily="34" charset="0"/>
-              <a:cs typeface="Arial" panose="020B0604020202020204" pitchFamily="34" charset="0"/>
-            </a:endParaRPr>
-          </a:p>
-          <a:p>
-            <a:pPr marL="514350" marR="0" lvl="0" indent="-514350" algn="just" rtl="0">
-              <a:lnSpc>
-                <a:spcPct val="90000"/>
-              </a:lnSpc>
-              <a:spcBef>
-                <a:spcPts val="1000"/>
-              </a:spcBef>
-              <a:spcAft>
-                <a:spcPts val="0"/>
-              </a:spcAft>
-              <a:buClr>
-                <a:schemeClr val="dk1"/>
-              </a:buClr>
-              <a:buSzPct val="100000"/>
-              <a:buFont typeface="Calibri"/>
-              <a:buAutoNum type="arabicPeriod"/>
-            </a:pPr>
-            <a:r>
-              <a:rPr lang="en-US" b="1" i="0" u="none" strike="noStrike" cap="none" dirty="0">
-                <a:solidFill>
-                  <a:schemeClr val="dk1"/>
-                </a:solidFill>
-                <a:latin typeface="Arial" panose="020B0604020202020204" pitchFamily="34" charset="0"/>
-                <a:ea typeface="Calibri"/>
-                <a:cs typeface="Arial" panose="020B0604020202020204" pitchFamily="34" charset="0"/>
-                <a:sym typeface="Calibri"/>
-              </a:rPr>
-              <a:t>You can only use provided </a:t>
-            </a:r>
-            <a:r>
-              <a:rPr lang="en-US" b="1" dirty="0">
-                <a:solidFill>
-                  <a:schemeClr val="dk1"/>
-                </a:solidFill>
-                <a:latin typeface="Arial" panose="020B0604020202020204" pitchFamily="34" charset="0"/>
-                <a:ea typeface="Calibri"/>
-                <a:cs typeface="Arial" panose="020B0604020202020204" pitchFamily="34" charset="0"/>
-                <a:sym typeface="Calibri"/>
-              </a:rPr>
-              <a:t>template</a:t>
-            </a:r>
-            <a:r>
-              <a:rPr lang="en-US" b="1" i="0" u="none" strike="noStrike" cap="none" dirty="0">
-                <a:solidFill>
-                  <a:schemeClr val="dk1"/>
-                </a:solidFill>
-                <a:latin typeface="Arial" panose="020B0604020202020204" pitchFamily="34" charset="0"/>
-                <a:ea typeface="Calibri"/>
-                <a:cs typeface="Arial" panose="020B0604020202020204" pitchFamily="34" charset="0"/>
-                <a:sym typeface="Calibri"/>
-              </a:rPr>
-              <a:t> for making the </a:t>
-            </a:r>
-            <a:r>
-              <a:rPr lang="en-US" b="1" dirty="0">
-                <a:solidFill>
-                  <a:schemeClr val="dk1"/>
-                </a:solidFill>
-                <a:latin typeface="Arial" panose="020B0604020202020204" pitchFamily="34" charset="0"/>
-                <a:ea typeface="Calibri"/>
-                <a:cs typeface="Arial" panose="020B0604020202020204" pitchFamily="34" charset="0"/>
-                <a:sym typeface="Calibri"/>
-              </a:rPr>
-              <a:t>PPT</a:t>
-            </a:r>
-            <a:r>
-              <a:rPr lang="en-US" b="1" i="0" u="none" strike="noStrike" cap="none" dirty="0">
-                <a:solidFill>
-                  <a:schemeClr val="dk1"/>
-                </a:solidFill>
-                <a:latin typeface="Arial" panose="020B0604020202020204" pitchFamily="34" charset="0"/>
-                <a:ea typeface="Calibri"/>
-                <a:cs typeface="Arial" panose="020B0604020202020204" pitchFamily="34" charset="0"/>
-                <a:sym typeface="Calibri"/>
-              </a:rPr>
-              <a:t> without changing the idea details pointers (mentioned in previous slides).</a:t>
-            </a:r>
-            <a:endParaRPr b="1" i="0" u="none" strike="noStrike" cap="none" dirty="0">
-              <a:solidFill>
-                <a:schemeClr val="dk1"/>
-              </a:solidFill>
-              <a:latin typeface="Arial" panose="020B0604020202020204" pitchFamily="34" charset="0"/>
-              <a:ea typeface="Calibri"/>
-              <a:cs typeface="Arial" panose="020B0604020202020204" pitchFamily="34" charset="0"/>
-              <a:sym typeface="Calibri"/>
-            </a:endParaRPr>
-          </a:p>
-          <a:p>
-            <a:pPr marL="514350" marR="0" lvl="0" indent="-514350" algn="just" rtl="0">
-              <a:lnSpc>
-                <a:spcPct val="90000"/>
-              </a:lnSpc>
-              <a:spcBef>
-                <a:spcPts val="1000"/>
-              </a:spcBef>
-              <a:spcAft>
-                <a:spcPts val="0"/>
-              </a:spcAft>
-              <a:buClr>
-                <a:schemeClr val="dk1"/>
-              </a:buClr>
-              <a:buSzPct val="100000"/>
-              <a:buFont typeface="Calibri"/>
-              <a:buAutoNum type="arabicPeriod"/>
-            </a:pPr>
-            <a:r>
-              <a:rPr lang="en-US" b="1" i="0" u="none" strike="noStrike" cap="none" dirty="0">
-                <a:solidFill>
-                  <a:schemeClr val="dk1"/>
-                </a:solidFill>
-                <a:latin typeface="Arial" panose="020B0604020202020204" pitchFamily="34" charset="0"/>
-                <a:ea typeface="Calibri"/>
-                <a:cs typeface="Arial" panose="020B0604020202020204" pitchFamily="34" charset="0"/>
-                <a:sym typeface="Calibri"/>
-              </a:rPr>
-              <a:t>You need to save the file in PDF and upload the same on portal. No PPT, Word Doc or any other format will be supported.</a:t>
-            </a:r>
-            <a:endParaRPr b="1" dirty="0">
-              <a:latin typeface="Arial" panose="020B0604020202020204" pitchFamily="34" charset="0"/>
-              <a:cs typeface="Arial" panose="020B0604020202020204" pitchFamily="34" charset="0"/>
-            </a:endParaRPr>
-          </a:p>
-          <a:p>
-            <a:pPr marL="514350" marR="0" lvl="0" indent="-349885" algn="just" rtl="0">
-              <a:lnSpc>
-                <a:spcPct val="90000"/>
-              </a:lnSpc>
-              <a:spcBef>
-                <a:spcPts val="1000"/>
-              </a:spcBef>
-              <a:spcAft>
-                <a:spcPts val="0"/>
-              </a:spcAft>
-              <a:buClr>
-                <a:schemeClr val="dk1"/>
-              </a:buClr>
-              <a:buSzPct val="100000"/>
-              <a:buFont typeface="Calibri"/>
-              <a:buNone/>
-            </a:pPr>
-            <a:endParaRPr b="1" i="0" u="none" strike="noStrike" cap="none" dirty="0">
-              <a:solidFill>
-                <a:schemeClr val="dk1"/>
-              </a:solidFill>
-              <a:latin typeface="Arial" panose="020B0604020202020204" pitchFamily="34" charset="0"/>
-              <a:ea typeface="Calibri"/>
-              <a:cs typeface="Arial" panose="020B0604020202020204" pitchFamily="34" charset="0"/>
-              <a:sym typeface="Calibri"/>
-            </a:endParaRPr>
-          </a:p>
-          <a:p>
-            <a:pPr marL="0" marR="0" lvl="0" indent="0" algn="just" rtl="0">
-              <a:lnSpc>
-                <a:spcPct val="90000"/>
-              </a:lnSpc>
-              <a:spcBef>
-                <a:spcPts val="1000"/>
-              </a:spcBef>
-              <a:spcAft>
-                <a:spcPts val="0"/>
-              </a:spcAft>
-              <a:buClr>
-                <a:schemeClr val="dk1"/>
-              </a:buClr>
-              <a:buSzPct val="100000"/>
-              <a:buFont typeface="Arial"/>
-              <a:buNone/>
-            </a:pPr>
-            <a:r>
-              <a:rPr lang="en-US" b="1" i="0" u="none" strike="noStrike" cap="none" dirty="0">
-                <a:solidFill>
-                  <a:srgbClr val="C00000"/>
-                </a:solidFill>
-                <a:latin typeface="Arial" panose="020B0604020202020204" pitchFamily="34" charset="0"/>
-                <a:ea typeface="Calibri"/>
-                <a:cs typeface="Arial" panose="020B0604020202020204" pitchFamily="34" charset="0"/>
-                <a:sym typeface="Calibri"/>
-              </a:rPr>
-              <a:t>Note - You can delete this slide (Important Pointers) when you upload the details of your idea on SIH portal.</a:t>
-            </a:r>
-            <a:endParaRPr b="1" dirty="0">
-              <a:solidFill>
-                <a:srgbClr val="C00000"/>
-              </a:solidFill>
-              <a:latin typeface="Arial" panose="020B0604020202020204" pitchFamily="34" charset="0"/>
-              <a:cs typeface="Arial" panose="020B0604020202020204" pitchFamily="34" charset="0"/>
-            </a:endParaRPr>
-          </a:p>
-          <a:p>
-            <a:pPr marL="914400" marR="0" lvl="1" indent="-316230" algn="just" rtl="0">
-              <a:lnSpc>
-                <a:spcPct val="90000"/>
-              </a:lnSpc>
-              <a:spcBef>
-                <a:spcPts val="500"/>
-              </a:spcBef>
-              <a:spcAft>
-                <a:spcPts val="0"/>
-              </a:spcAft>
-              <a:buClr>
-                <a:schemeClr val="dk1"/>
-              </a:buClr>
-              <a:buSzPct val="100000"/>
-              <a:buFont typeface="Calibri"/>
-              <a:buNone/>
-            </a:pPr>
-            <a:endParaRPr sz="2000" b="1" i="0" u="none" strike="noStrike" cap="none" dirty="0">
-              <a:solidFill>
-                <a:schemeClr val="dk1"/>
-              </a:solidFill>
-              <a:latin typeface="Arial" panose="020B0604020202020204" pitchFamily="34" charset="0"/>
-              <a:ea typeface="Calibri"/>
-              <a:cs typeface="Arial" panose="020B0604020202020204" pitchFamily="34" charset="0"/>
-              <a:sym typeface="Calibri"/>
-            </a:endParaRPr>
-          </a:p>
-        </p:txBody>
-      </p:sp>
-      <p:sp>
-        <p:nvSpPr>
-          <p:cNvPr id="4" name="TextBox 3"/>
-          <p:cNvSpPr txBox="1"/>
-          <p:nvPr/>
-        </p:nvSpPr>
-        <p:spPr>
-          <a:xfrm>
-            <a:off x="1393371" y="107066"/>
-            <a:ext cx="8410540" cy="646331"/>
-          </a:xfrm>
-          <a:prstGeom prst="rect">
-            <a:avLst/>
-          </a:prstGeom>
-          <a:noFill/>
-        </p:spPr>
-        <p:txBody>
-          <a:bodyPr wrap="square" rtlCol="0">
-            <a:spAutoFit/>
-          </a:bodyPr>
-          <a:lstStyle/>
-          <a:p>
-            <a:pPr algn="ctr"/>
-            <a:r>
-              <a:rPr lang="en-US" sz="3600" b="1" dirty="0">
-                <a:latin typeface="Times New Roman" panose="02020603050405020304" pitchFamily="18" charset="0"/>
-                <a:cs typeface="Times New Roman" panose="02020603050405020304" pitchFamily="18" charset="0"/>
-              </a:rPr>
-              <a:t>IMPORTANT INSTRUCTIONS</a:t>
-            </a:r>
-            <a:endParaRPr lang="en-IN" sz="3600" b="1" dirty="0">
-              <a:latin typeface="Times New Roman" panose="02020603050405020304" pitchFamily="18" charset="0"/>
-              <a:cs typeface="Times New Roman" panose="02020603050405020304" pitchFamily="18" charset="0"/>
-            </a:endParaRPr>
-          </a:p>
-        </p:txBody>
-      </p:sp>
-      <p:sp>
-        <p:nvSpPr>
-          <p:cNvPr id="5" name="TextBox 4"/>
-          <p:cNvSpPr txBox="1"/>
-          <p:nvPr/>
-        </p:nvSpPr>
-        <p:spPr>
-          <a:xfrm>
-            <a:off x="602343" y="1181900"/>
-            <a:ext cx="9557657" cy="341632"/>
-          </a:xfrm>
-          <a:prstGeom prst="rect">
-            <a:avLst/>
-          </a:prstGeom>
-          <a:noFill/>
-        </p:spPr>
-        <p:txBody>
-          <a:bodyPr wrap="square" rtlCol="0">
-            <a:spAutoFit/>
-          </a:bodyPr>
-          <a:lstStyle/>
-          <a:p>
-            <a:pPr algn="just">
-              <a:lnSpc>
-                <a:spcPct val="90000"/>
-              </a:lnSpc>
-              <a:spcBef>
-                <a:spcPts val="1000"/>
-              </a:spcBef>
-              <a:spcAft>
-                <a:spcPts val="0"/>
-              </a:spcAft>
-              <a:buClr>
-                <a:schemeClr val="dk1"/>
-              </a:buClr>
-              <a:buSzPct val="100000"/>
-            </a:pPr>
-            <a:r>
-              <a:rPr lang="en-US" b="1" dirty="0">
-                <a:solidFill>
-                  <a:schemeClr val="dk1"/>
-                </a:solidFill>
-                <a:latin typeface="Arial" panose="020B0604020202020204" pitchFamily="34" charset="0"/>
-                <a:ea typeface="Calibri"/>
-                <a:cs typeface="Arial" panose="020B0604020202020204" pitchFamily="34" charset="0"/>
-              </a:rPr>
-              <a:t>Please ensure below pointers are met while submitting the Idea PPT:</a:t>
-            </a:r>
-            <a:endParaRPr lang="en-IN" b="1" dirty="0">
-              <a:solidFill>
-                <a:schemeClr val="dk1"/>
-              </a:solidFill>
-              <a:latin typeface="Arial" panose="020B0604020202020204" pitchFamily="34" charset="0"/>
-              <a:ea typeface="Calibri"/>
-              <a:cs typeface="Arial" panose="020B0604020202020204" pitchFamily="34" charset="0"/>
-            </a:endParaRPr>
-          </a:p>
-        </p:txBody>
-      </p:sp>
-      <p:pic>
-        <p:nvPicPr>
-          <p:cNvPr id="13" name="Picture 12"/>
-          <p:cNvPicPr>
-            <a:picLocks noChangeAspect="1"/>
-          </p:cNvPicPr>
-          <p:nvPr/>
-        </p:nvPicPr>
-        <p:blipFill>
-          <a:blip r:embed="rId3">
-            <a:extLst>
-              <a:ext uri="{28A0092B-C50C-407E-A947-70E740481C1C}">
-                <a14:useLocalDpi xmlns:a14="http://schemas.microsoft.com/office/drawing/2010/main" val="0"/>
-              </a:ext>
-            </a:extLst>
-          </a:blip>
-          <a:stretch>
-            <a:fillRect/>
-          </a:stretch>
-        </p:blipFill>
-        <p:spPr>
-          <a:xfrm>
-            <a:off x="9780086" y="1500"/>
-            <a:ext cx="2249850" cy="1062337"/>
-          </a:xfrm>
-          <a:prstGeom prst="rect">
-            <a:avLst/>
-          </a:prstGeom>
-        </p:spPr>
-      </p:pic>
-    </p:spTree>
-    <p:extLst>
-      <p:ext uri="{BB962C8B-B14F-4D97-AF65-F5344CB8AC3E}">
-        <p14:creationId xmlns:p14="http://schemas.microsoft.com/office/powerpoint/2010/main" val="1588084416"/>
       </p:ext>
     </p:extLst>
   </p:cSld>

</xml_diff>